<commit_message>
Expand EvacOS2 presentation tech stack
</commit_message>
<xml_diff>
--- a/deliverables/EvacOS2_presentation.pptx
+++ b/deliverables/EvacOS2_presentation.pptx
@@ -17,6 +17,10 @@
     <p:sldId id="265" r:id="rId16"/>
     <p:sldId id="266" r:id="rId17"/>
     <p:sldId id="267" r:id="rId18"/>
+    <p:sldId id="268" r:id="rId19"/>
+    <p:sldId id="269" r:id="rId20"/>
+    <p:sldId id="270" r:id="rId21"/>
+    <p:sldId id="271" r:id="rId22"/>
   </p:sldIdLst>
   <p:sldSz cx="12191695" cy="6858000" type="screen4x3"/>
   <p:notesSz cx="6858000" cy="9144000"/>
@@ -5614,6 +5618,3904 @@
             </a:pPr>
             <a:r>
               <a:t>Thank you</a:t>
+            </a:r>
+          </a:p>
+        </p:txBody>
+      </p:sp>
+    </p:spTree>
+  </p:cSld>
+  <p:clrMapOvr>
+    <a:masterClrMapping/>
+  </p:clrMapOvr>
+</p:sld>
+</file>
+
+<file path=ppt/slides/slide13.xml><?xml version="1.0" encoding="utf-8"?>
+<p:sld xmlns:a="http://schemas.openxmlformats.org/drawingml/2006/main" xmlns:p="http://schemas.openxmlformats.org/presentationml/2006/main" xmlns:r="http://schemas.openxmlformats.org/officeDocument/2006/relationships">
+  <p:cSld>
+    <p:spTree>
+      <p:nvGrpSpPr>
+        <p:cNvPr id="1" name=""/>
+        <p:cNvGrpSpPr/>
+        <p:nvPr/>
+      </p:nvGrpSpPr>
+      <p:grpSpPr/>
+      <p:sp>
+        <p:nvSpPr>
+          <p:cNvPr id="2" name="Rectangle 1"/>
+          <p:cNvSpPr/>
+          <p:nvPr/>
+        </p:nvSpPr>
+        <p:spPr>
+          <a:xfrm>
+            <a:off x="0" y="0"/>
+            <a:ext cx="12191695" cy="6858000"/>
+          </a:xfrm>
+          <a:prstGeom prst="rect">
+            <a:avLst/>
+          </a:prstGeom>
+          <a:solidFill>
+            <a:srgbClr val="F8F4E8"/>
+          </a:solidFill>
+          <a:ln>
+            <a:noFill/>
+          </a:ln>
+        </p:spPr>
+        <p:style>
+          <a:lnRef idx="1">
+            <a:schemeClr val="accent1"/>
+          </a:lnRef>
+          <a:fillRef idx="3">
+            <a:schemeClr val="accent1"/>
+          </a:fillRef>
+          <a:effectRef idx="2">
+            <a:schemeClr val="accent1"/>
+          </a:effectRef>
+          <a:fontRef idx="minor">
+            <a:schemeClr val="lt1"/>
+          </a:fontRef>
+        </p:style>
+        <p:txBody>
+          <a:bodyPr rtlCol="0" anchor="ctr"/>
+          <a:lstStyle/>
+          <a:p>
+            <a:pPr algn="ctr"/>
+          </a:p>
+        </p:txBody>
+      </p:sp>
+      <p:sp>
+        <p:nvSpPr>
+          <p:cNvPr id="3" name="TextBox 2"/>
+          <p:cNvSpPr txBox="1"/>
+          <p:nvPr/>
+        </p:nvSpPr>
+        <p:spPr>
+          <a:xfrm>
+            <a:off x="594360" y="384048"/>
+            <a:ext cx="10972800" cy="457200"/>
+          </a:xfrm>
+          <a:prstGeom prst="rect">
+            <a:avLst/>
+          </a:prstGeom>
+          <a:noFill/>
+        </p:spPr>
+        <p:txBody>
+          <a:bodyPr wrap="square">
+            <a:spAutoFit/>
+          </a:bodyPr>
+          <a:lstStyle/>
+          <a:p>
+            <a:pPr algn="l"/>
+            <a:r>
+              <a:rPr sz="1500" b="1">
+                <a:solidFill>
+                  <a:srgbClr val="EF7C3A"/>
+                </a:solidFill>
+                <a:latin typeface="Aptos"/>
+              </a:rPr>
+              <a:t>TECH STACK</a:t>
+            </a:r>
+          </a:p>
+        </p:txBody>
+      </p:sp>
+      <p:sp>
+        <p:nvSpPr>
+          <p:cNvPr id="4" name="TextBox 3"/>
+          <p:cNvSpPr txBox="1"/>
+          <p:nvPr/>
+        </p:nvSpPr>
+        <p:spPr>
+          <a:xfrm>
+            <a:off x="594360" y="804672"/>
+            <a:ext cx="10789920" cy="713232"/>
+          </a:xfrm>
+          <a:prstGeom prst="rect">
+            <a:avLst/>
+          </a:prstGeom>
+          <a:noFill/>
+        </p:spPr>
+        <p:txBody>
+          <a:bodyPr wrap="square">
+            <a:spAutoFit/>
+          </a:bodyPr>
+          <a:lstStyle/>
+          <a:p>
+            <a:pPr algn="l"/>
+            <a:r>
+              <a:rPr sz="3000" b="1">
+                <a:solidFill>
+                  <a:srgbClr val="0E162B"/>
+                </a:solidFill>
+                <a:latin typeface="Georgia"/>
+              </a:rPr>
+              <a:t>What the system is actually built on</a:t>
+            </a:r>
+          </a:p>
+        </p:txBody>
+      </p:sp>
+      <p:sp>
+        <p:nvSpPr>
+          <p:cNvPr id="5" name="Rounded Rectangle 4"/>
+          <p:cNvSpPr/>
+          <p:nvPr/>
+        </p:nvSpPr>
+        <p:spPr>
+          <a:xfrm>
+            <a:off x="594360" y="1572768"/>
+            <a:ext cx="2148840" cy="384048"/>
+          </a:xfrm>
+          <a:prstGeom prst="roundRect">
+            <a:avLst/>
+          </a:prstGeom>
+          <a:solidFill>
+            <a:srgbClr val="23847A"/>
+          </a:solidFill>
+          <a:ln>
+            <a:noFill/>
+          </a:ln>
+        </p:spPr>
+        <p:style>
+          <a:lnRef idx="1">
+            <a:schemeClr val="accent1"/>
+          </a:lnRef>
+          <a:fillRef idx="3">
+            <a:schemeClr val="accent1"/>
+          </a:fillRef>
+          <a:effectRef idx="2">
+            <a:schemeClr val="accent1"/>
+          </a:effectRef>
+          <a:fontRef idx="minor">
+            <a:schemeClr val="lt1"/>
+          </a:fontRef>
+        </p:style>
+        <p:txBody>
+          <a:bodyPr rtlCol="0" anchor="ctr"/>
+          <a:lstStyle/>
+          <a:p>
+            <a:pPr algn="ctr"/>
+          </a:p>
+        </p:txBody>
+      </p:sp>
+      <p:sp>
+        <p:nvSpPr>
+          <p:cNvPr id="6" name="TextBox 5"/>
+          <p:cNvSpPr txBox="1"/>
+          <p:nvPr/>
+        </p:nvSpPr>
+        <p:spPr>
+          <a:xfrm>
+            <a:off x="667512" y="1655064"/>
+            <a:ext cx="1993392" cy="201168"/>
+          </a:xfrm>
+          <a:prstGeom prst="rect">
+            <a:avLst/>
+          </a:prstGeom>
+          <a:noFill/>
+        </p:spPr>
+        <p:txBody>
+          <a:bodyPr wrap="square">
+            <a:spAutoFit/>
+          </a:bodyPr>
+          <a:lstStyle/>
+          <a:p>
+            <a:pPr algn="ctr"/>
+            <a:r>
+              <a:rPr sz="1050" b="1">
+                <a:solidFill>
+                  <a:srgbClr val="FFFFFF"/>
+                </a:solidFill>
+                <a:latin typeface="Aptos"/>
+              </a:rPr>
+              <a:t>OpenEnv API</a:t>
+            </a:r>
+          </a:p>
+        </p:txBody>
+      </p:sp>
+      <p:sp>
+        <p:nvSpPr>
+          <p:cNvPr id="7" name="Rounded Rectangle 6"/>
+          <p:cNvSpPr/>
+          <p:nvPr/>
+        </p:nvSpPr>
+        <p:spPr>
+          <a:xfrm>
+            <a:off x="2907792" y="1572768"/>
+            <a:ext cx="2148840" cy="384048"/>
+          </a:xfrm>
+          <a:prstGeom prst="roundRect">
+            <a:avLst/>
+          </a:prstGeom>
+          <a:solidFill>
+            <a:srgbClr val="0E162B"/>
+          </a:solidFill>
+          <a:ln>
+            <a:noFill/>
+          </a:ln>
+        </p:spPr>
+        <p:style>
+          <a:lnRef idx="1">
+            <a:schemeClr val="accent1"/>
+          </a:lnRef>
+          <a:fillRef idx="3">
+            <a:schemeClr val="accent1"/>
+          </a:fillRef>
+          <a:effectRef idx="2">
+            <a:schemeClr val="accent1"/>
+          </a:effectRef>
+          <a:fontRef idx="minor">
+            <a:schemeClr val="lt1"/>
+          </a:fontRef>
+        </p:style>
+        <p:txBody>
+          <a:bodyPr rtlCol="0" anchor="ctr"/>
+          <a:lstStyle/>
+          <a:p>
+            <a:pPr algn="ctr"/>
+          </a:p>
+        </p:txBody>
+      </p:sp>
+      <p:sp>
+        <p:nvSpPr>
+          <p:cNvPr id="8" name="TextBox 7"/>
+          <p:cNvSpPr txBox="1"/>
+          <p:nvPr/>
+        </p:nvSpPr>
+        <p:spPr>
+          <a:xfrm>
+            <a:off x="2980944" y="1655064"/>
+            <a:ext cx="1993392" cy="201168"/>
+          </a:xfrm>
+          <a:prstGeom prst="rect">
+            <a:avLst/>
+          </a:prstGeom>
+          <a:noFill/>
+        </p:spPr>
+        <p:txBody>
+          <a:bodyPr wrap="square">
+            <a:spAutoFit/>
+          </a:bodyPr>
+          <a:lstStyle/>
+          <a:p>
+            <a:pPr algn="ctr"/>
+            <a:r>
+              <a:rPr sz="1050" b="1">
+                <a:solidFill>
+                  <a:srgbClr val="FFFFFF"/>
+                </a:solidFill>
+                <a:latin typeface="Aptos"/>
+              </a:rPr>
+              <a:t>Qwen2.5</a:t>
+            </a:r>
+          </a:p>
+        </p:txBody>
+      </p:sp>
+      <p:sp>
+        <p:nvSpPr>
+          <p:cNvPr id="9" name="Rounded Rectangle 8"/>
+          <p:cNvSpPr/>
+          <p:nvPr/>
+        </p:nvSpPr>
+        <p:spPr>
+          <a:xfrm>
+            <a:off x="5221224" y="1572768"/>
+            <a:ext cx="2148840" cy="384048"/>
+          </a:xfrm>
+          <a:prstGeom prst="roundRect">
+            <a:avLst/>
+          </a:prstGeom>
+          <a:solidFill>
+            <a:srgbClr val="EF7C3A"/>
+          </a:solidFill>
+          <a:ln>
+            <a:noFill/>
+          </a:ln>
+        </p:spPr>
+        <p:style>
+          <a:lnRef idx="1">
+            <a:schemeClr val="accent1"/>
+          </a:lnRef>
+          <a:fillRef idx="3">
+            <a:schemeClr val="accent1"/>
+          </a:fillRef>
+          <a:effectRef idx="2">
+            <a:schemeClr val="accent1"/>
+          </a:effectRef>
+          <a:fontRef idx="minor">
+            <a:schemeClr val="lt1"/>
+          </a:fontRef>
+        </p:style>
+        <p:txBody>
+          <a:bodyPr rtlCol="0" anchor="ctr"/>
+          <a:lstStyle/>
+          <a:p>
+            <a:pPr algn="ctr"/>
+          </a:p>
+        </p:txBody>
+      </p:sp>
+      <p:sp>
+        <p:nvSpPr>
+          <p:cNvPr id="10" name="TextBox 9"/>
+          <p:cNvSpPr txBox="1"/>
+          <p:nvPr/>
+        </p:nvSpPr>
+        <p:spPr>
+          <a:xfrm>
+            <a:off x="5294376" y="1655064"/>
+            <a:ext cx="1993392" cy="201168"/>
+          </a:xfrm>
+          <a:prstGeom prst="rect">
+            <a:avLst/>
+          </a:prstGeom>
+          <a:noFill/>
+        </p:spPr>
+        <p:txBody>
+          <a:bodyPr wrap="square">
+            <a:spAutoFit/>
+          </a:bodyPr>
+          <a:lstStyle/>
+          <a:p>
+            <a:pPr algn="ctr"/>
+            <a:r>
+              <a:rPr sz="1050" b="1">
+                <a:solidFill>
+                  <a:srgbClr val="FFFFFF"/>
+                </a:solidFill>
+                <a:latin typeface="Aptos"/>
+              </a:rPr>
+              <a:t>Unsloth</a:t>
+            </a:r>
+          </a:p>
+        </p:txBody>
+      </p:sp>
+      <p:sp>
+        <p:nvSpPr>
+          <p:cNvPr id="11" name="Rounded Rectangle 10"/>
+          <p:cNvSpPr/>
+          <p:nvPr/>
+        </p:nvSpPr>
+        <p:spPr>
+          <a:xfrm>
+            <a:off x="7534656" y="1572768"/>
+            <a:ext cx="2148840" cy="384048"/>
+          </a:xfrm>
+          <a:prstGeom prst="roundRect">
+            <a:avLst/>
+          </a:prstGeom>
+          <a:solidFill>
+            <a:srgbClr val="23847A"/>
+          </a:solidFill>
+          <a:ln>
+            <a:noFill/>
+          </a:ln>
+        </p:spPr>
+        <p:style>
+          <a:lnRef idx="1">
+            <a:schemeClr val="accent1"/>
+          </a:lnRef>
+          <a:fillRef idx="3">
+            <a:schemeClr val="accent1"/>
+          </a:fillRef>
+          <a:effectRef idx="2">
+            <a:schemeClr val="accent1"/>
+          </a:effectRef>
+          <a:fontRef idx="minor">
+            <a:schemeClr val="lt1"/>
+          </a:fontRef>
+        </p:style>
+        <p:txBody>
+          <a:bodyPr rtlCol="0" anchor="ctr"/>
+          <a:lstStyle/>
+          <a:p>
+            <a:pPr algn="ctr"/>
+          </a:p>
+        </p:txBody>
+      </p:sp>
+      <p:sp>
+        <p:nvSpPr>
+          <p:cNvPr id="12" name="TextBox 11"/>
+          <p:cNvSpPr txBox="1"/>
+          <p:nvPr/>
+        </p:nvSpPr>
+        <p:spPr>
+          <a:xfrm>
+            <a:off x="7607808" y="1655064"/>
+            <a:ext cx="1993392" cy="201168"/>
+          </a:xfrm>
+          <a:prstGeom prst="rect">
+            <a:avLst/>
+          </a:prstGeom>
+          <a:noFill/>
+        </p:spPr>
+        <p:txBody>
+          <a:bodyPr wrap="square">
+            <a:spAutoFit/>
+          </a:bodyPr>
+          <a:lstStyle/>
+          <a:p>
+            <a:pPr algn="ctr"/>
+            <a:r>
+              <a:rPr sz="1050" b="1">
+                <a:solidFill>
+                  <a:srgbClr val="FFFFFF"/>
+                </a:solidFill>
+                <a:latin typeface="Aptos"/>
+              </a:rPr>
+              <a:t>LoRA adapters</a:t>
+            </a:r>
+          </a:p>
+        </p:txBody>
+      </p:sp>
+      <p:sp>
+        <p:nvSpPr>
+          <p:cNvPr id="13" name="Rounded Rectangle 12"/>
+          <p:cNvSpPr/>
+          <p:nvPr/>
+        </p:nvSpPr>
+        <p:spPr>
+          <a:xfrm>
+            <a:off x="9848088" y="1572768"/>
+            <a:ext cx="2148840" cy="384048"/>
+          </a:xfrm>
+          <a:prstGeom prst="roundRect">
+            <a:avLst/>
+          </a:prstGeom>
+          <a:solidFill>
+            <a:srgbClr val="0E162B"/>
+          </a:solidFill>
+          <a:ln>
+            <a:noFill/>
+          </a:ln>
+        </p:spPr>
+        <p:style>
+          <a:lnRef idx="1">
+            <a:schemeClr val="accent1"/>
+          </a:lnRef>
+          <a:fillRef idx="3">
+            <a:schemeClr val="accent1"/>
+          </a:fillRef>
+          <a:effectRef idx="2">
+            <a:schemeClr val="accent1"/>
+          </a:effectRef>
+          <a:fontRef idx="minor">
+            <a:schemeClr val="lt1"/>
+          </a:fontRef>
+        </p:style>
+        <p:txBody>
+          <a:bodyPr rtlCol="0" anchor="ctr"/>
+          <a:lstStyle/>
+          <a:p>
+            <a:pPr algn="ctr"/>
+          </a:p>
+        </p:txBody>
+      </p:sp>
+      <p:sp>
+        <p:nvSpPr>
+          <p:cNvPr id="14" name="TextBox 13"/>
+          <p:cNvSpPr txBox="1"/>
+          <p:nvPr/>
+        </p:nvSpPr>
+        <p:spPr>
+          <a:xfrm>
+            <a:off x="9921240" y="1655064"/>
+            <a:ext cx="1993392" cy="201168"/>
+          </a:xfrm>
+          <a:prstGeom prst="rect">
+            <a:avLst/>
+          </a:prstGeom>
+          <a:noFill/>
+        </p:spPr>
+        <p:txBody>
+          <a:bodyPr wrap="square">
+            <a:spAutoFit/>
+          </a:bodyPr>
+          <a:lstStyle/>
+          <a:p>
+            <a:pPr algn="ctr"/>
+            <a:r>
+              <a:rPr sz="1050" b="1">
+                <a:solidFill>
+                  <a:srgbClr val="FFFFFF"/>
+                </a:solidFill>
+                <a:latin typeface="Aptos"/>
+              </a:rPr>
+              <a:t>HF Spaces</a:t>
+            </a:r>
+          </a:p>
+        </p:txBody>
+      </p:sp>
+      <p:sp>
+        <p:nvSpPr>
+          <p:cNvPr id="15" name="Rounded Rectangle 14"/>
+          <p:cNvSpPr/>
+          <p:nvPr/>
+        </p:nvSpPr>
+        <p:spPr>
+          <a:xfrm>
+            <a:off x="685800" y="2267712"/>
+            <a:ext cx="3401568" cy="1536192"/>
+          </a:xfrm>
+          <a:prstGeom prst="roundRect">
+            <a:avLst/>
+          </a:prstGeom>
+          <a:solidFill>
+            <a:srgbClr val="FFFFFF"/>
+          </a:solidFill>
+          <a:ln w="12700">
+            <a:solidFill>
+              <a:srgbClr val="E1E6EB"/>
+            </a:solidFill>
+          </a:ln>
+        </p:spPr>
+        <p:style>
+          <a:lnRef idx="1">
+            <a:schemeClr val="accent1"/>
+          </a:lnRef>
+          <a:fillRef idx="3">
+            <a:schemeClr val="accent1"/>
+          </a:fillRef>
+          <a:effectRef idx="2">
+            <a:schemeClr val="accent1"/>
+          </a:effectRef>
+          <a:fontRef idx="minor">
+            <a:schemeClr val="lt1"/>
+          </a:fontRef>
+        </p:style>
+        <p:txBody>
+          <a:bodyPr rtlCol="0" anchor="ctr"/>
+          <a:lstStyle/>
+          <a:p>
+            <a:pPr algn="ctr"/>
+          </a:p>
+        </p:txBody>
+      </p:sp>
+      <p:sp>
+        <p:nvSpPr>
+          <p:cNvPr id="16" name="Rectangle 15"/>
+          <p:cNvSpPr/>
+          <p:nvPr/>
+        </p:nvSpPr>
+        <p:spPr>
+          <a:xfrm>
+            <a:off x="685800" y="2267712"/>
+            <a:ext cx="73152" cy="1536192"/>
+          </a:xfrm>
+          <a:prstGeom prst="rect">
+            <a:avLst/>
+          </a:prstGeom>
+          <a:solidFill>
+            <a:srgbClr val="23847A"/>
+          </a:solidFill>
+          <a:ln>
+            <a:noFill/>
+          </a:ln>
+        </p:spPr>
+        <p:style>
+          <a:lnRef idx="1">
+            <a:schemeClr val="accent1"/>
+          </a:lnRef>
+          <a:fillRef idx="3">
+            <a:schemeClr val="accent1"/>
+          </a:fillRef>
+          <a:effectRef idx="2">
+            <a:schemeClr val="accent1"/>
+          </a:effectRef>
+          <a:fontRef idx="minor">
+            <a:schemeClr val="lt1"/>
+          </a:fontRef>
+        </p:style>
+        <p:txBody>
+          <a:bodyPr rtlCol="0" anchor="ctr"/>
+          <a:lstStyle/>
+          <a:p>
+            <a:pPr algn="ctr"/>
+          </a:p>
+        </p:txBody>
+      </p:sp>
+      <p:sp>
+        <p:nvSpPr>
+          <p:cNvPr id="17" name="TextBox 16"/>
+          <p:cNvSpPr txBox="1"/>
+          <p:nvPr/>
+        </p:nvSpPr>
+        <p:spPr>
+          <a:xfrm>
+            <a:off x="886968" y="2432304"/>
+            <a:ext cx="2990088" cy="274320"/>
+          </a:xfrm>
+          <a:prstGeom prst="rect">
+            <a:avLst/>
+          </a:prstGeom>
+          <a:noFill/>
+        </p:spPr>
+        <p:txBody>
+          <a:bodyPr wrap="square">
+            <a:spAutoFit/>
+          </a:bodyPr>
+          <a:lstStyle/>
+          <a:p>
+            <a:pPr algn="l"/>
+            <a:r>
+              <a:rPr sz="1600" b="1">
+                <a:solidFill>
+                  <a:srgbClr val="0E162B"/>
+                </a:solidFill>
+                <a:latin typeface="Aptos"/>
+              </a:rPr>
+              <a:t>Environment layer</a:t>
+            </a:r>
+          </a:p>
+        </p:txBody>
+      </p:sp>
+      <p:sp>
+        <p:nvSpPr>
+          <p:cNvPr id="18" name="TextBox 17"/>
+          <p:cNvSpPr txBox="1"/>
+          <p:nvPr/>
+        </p:nvSpPr>
+        <p:spPr>
+          <a:xfrm>
+            <a:off x="886968" y="2798064"/>
+            <a:ext cx="2990088" cy="896112"/>
+          </a:xfrm>
+          <a:prstGeom prst="rect">
+            <a:avLst/>
+          </a:prstGeom>
+          <a:noFill/>
+        </p:spPr>
+        <p:txBody>
+          <a:bodyPr wrap="square">
+            <a:spAutoFit/>
+          </a:bodyPr>
+          <a:lstStyle/>
+          <a:p>
+            <a:pPr algn="l"/>
+            <a:r>
+              <a:rPr sz="1300" b="0">
+                <a:solidFill>
+                  <a:srgbClr val="465266"/>
+                </a:solidFill>
+                <a:latin typeface="Aptos"/>
+              </a:rPr>
+              <a:t>Deterministic evacuation simulator with fire, flood, and gas lanes exposed through /openenv health, metadata, reset, step, and state endpoints.</a:t>
+            </a:r>
+          </a:p>
+        </p:txBody>
+      </p:sp>
+      <p:sp>
+        <p:nvSpPr>
+          <p:cNvPr id="19" name="Rounded Rectangle 18"/>
+          <p:cNvSpPr/>
+          <p:nvPr/>
+        </p:nvSpPr>
+        <p:spPr>
+          <a:xfrm>
+            <a:off x="4434840" y="2267712"/>
+            <a:ext cx="3401568" cy="1536192"/>
+          </a:xfrm>
+          <a:prstGeom prst="roundRect">
+            <a:avLst/>
+          </a:prstGeom>
+          <a:solidFill>
+            <a:srgbClr val="FFFFFF"/>
+          </a:solidFill>
+          <a:ln w="12700">
+            <a:solidFill>
+              <a:srgbClr val="E1E6EB"/>
+            </a:solidFill>
+          </a:ln>
+        </p:spPr>
+        <p:style>
+          <a:lnRef idx="1">
+            <a:schemeClr val="accent1"/>
+          </a:lnRef>
+          <a:fillRef idx="3">
+            <a:schemeClr val="accent1"/>
+          </a:fillRef>
+          <a:effectRef idx="2">
+            <a:schemeClr val="accent1"/>
+          </a:effectRef>
+          <a:fontRef idx="minor">
+            <a:schemeClr val="lt1"/>
+          </a:fontRef>
+        </p:style>
+        <p:txBody>
+          <a:bodyPr rtlCol="0" anchor="ctr"/>
+          <a:lstStyle/>
+          <a:p>
+            <a:pPr algn="ctr"/>
+          </a:p>
+        </p:txBody>
+      </p:sp>
+      <p:sp>
+        <p:nvSpPr>
+          <p:cNvPr id="20" name="Rectangle 19"/>
+          <p:cNvSpPr/>
+          <p:nvPr/>
+        </p:nvSpPr>
+        <p:spPr>
+          <a:xfrm>
+            <a:off x="4434840" y="2267712"/>
+            <a:ext cx="73152" cy="1536192"/>
+          </a:xfrm>
+          <a:prstGeom prst="rect">
+            <a:avLst/>
+          </a:prstGeom>
+          <a:solidFill>
+            <a:srgbClr val="EF7C3A"/>
+          </a:solidFill>
+          <a:ln>
+            <a:noFill/>
+          </a:ln>
+        </p:spPr>
+        <p:style>
+          <a:lnRef idx="1">
+            <a:schemeClr val="accent1"/>
+          </a:lnRef>
+          <a:fillRef idx="3">
+            <a:schemeClr val="accent1"/>
+          </a:fillRef>
+          <a:effectRef idx="2">
+            <a:schemeClr val="accent1"/>
+          </a:effectRef>
+          <a:fontRef idx="minor">
+            <a:schemeClr val="lt1"/>
+          </a:fontRef>
+        </p:style>
+        <p:txBody>
+          <a:bodyPr rtlCol="0" anchor="ctr"/>
+          <a:lstStyle/>
+          <a:p>
+            <a:pPr algn="ctr"/>
+          </a:p>
+        </p:txBody>
+      </p:sp>
+      <p:sp>
+        <p:nvSpPr>
+          <p:cNvPr id="21" name="TextBox 20"/>
+          <p:cNvSpPr txBox="1"/>
+          <p:nvPr/>
+        </p:nvSpPr>
+        <p:spPr>
+          <a:xfrm>
+            <a:off x="4636007" y="2432304"/>
+            <a:ext cx="2990088" cy="274320"/>
+          </a:xfrm>
+          <a:prstGeom prst="rect">
+            <a:avLst/>
+          </a:prstGeom>
+          <a:noFill/>
+        </p:spPr>
+        <p:txBody>
+          <a:bodyPr wrap="square">
+            <a:spAutoFit/>
+          </a:bodyPr>
+          <a:lstStyle/>
+          <a:p>
+            <a:pPr algn="l"/>
+            <a:r>
+              <a:rPr sz="1600" b="1">
+                <a:solidFill>
+                  <a:srgbClr val="0E162B"/>
+                </a:solidFill>
+                <a:latin typeface="Aptos"/>
+              </a:rPr>
+              <a:t>Training layer</a:t>
+            </a:r>
+          </a:p>
+        </p:txBody>
+      </p:sp>
+      <p:sp>
+        <p:nvSpPr>
+          <p:cNvPr id="22" name="TextBox 21"/>
+          <p:cNvSpPr txBox="1"/>
+          <p:nvPr/>
+        </p:nvSpPr>
+        <p:spPr>
+          <a:xfrm>
+            <a:off x="4636007" y="2798064"/>
+            <a:ext cx="2990088" cy="896112"/>
+          </a:xfrm>
+          <a:prstGeom prst="rect">
+            <a:avLst/>
+          </a:prstGeom>
+          <a:noFill/>
+        </p:spPr>
+        <p:txBody>
+          <a:bodyPr wrap="square">
+            <a:spAutoFit/>
+          </a:bodyPr>
+          <a:lstStyle/>
+          <a:p>
+            <a:pPr algn="l"/>
+            <a:r>
+              <a:rPr sz="1300" b="0">
+                <a:solidFill>
+                  <a:srgbClr val="465266"/>
+                </a:solidFill>
+                <a:latin typeface="Aptos"/>
+              </a:rPr>
+              <a:t>Unsloth backend, 4-bit base-model loading, PEFT LoRA adapters, GRPO-family reward optimization, checkpointed metrics and artifacts.</a:t>
+            </a:r>
+          </a:p>
+        </p:txBody>
+      </p:sp>
+      <p:sp>
+        <p:nvSpPr>
+          <p:cNvPr id="23" name="Rounded Rectangle 22"/>
+          <p:cNvSpPr/>
+          <p:nvPr/>
+        </p:nvSpPr>
+        <p:spPr>
+          <a:xfrm>
+            <a:off x="8183879" y="2267712"/>
+            <a:ext cx="3401568" cy="1536192"/>
+          </a:xfrm>
+          <a:prstGeom prst="roundRect">
+            <a:avLst/>
+          </a:prstGeom>
+          <a:solidFill>
+            <a:srgbClr val="FFFFFF"/>
+          </a:solidFill>
+          <a:ln w="12700">
+            <a:solidFill>
+              <a:srgbClr val="E1E6EB"/>
+            </a:solidFill>
+          </a:ln>
+        </p:spPr>
+        <p:style>
+          <a:lnRef idx="1">
+            <a:schemeClr val="accent1"/>
+          </a:lnRef>
+          <a:fillRef idx="3">
+            <a:schemeClr val="accent1"/>
+          </a:fillRef>
+          <a:effectRef idx="2">
+            <a:schemeClr val="accent1"/>
+          </a:effectRef>
+          <a:fontRef idx="minor">
+            <a:schemeClr val="lt1"/>
+          </a:fontRef>
+        </p:style>
+        <p:txBody>
+          <a:bodyPr rtlCol="0" anchor="ctr"/>
+          <a:lstStyle/>
+          <a:p>
+            <a:pPr algn="ctr"/>
+          </a:p>
+        </p:txBody>
+      </p:sp>
+      <p:sp>
+        <p:nvSpPr>
+          <p:cNvPr id="24" name="Rectangle 23"/>
+          <p:cNvSpPr/>
+          <p:nvPr/>
+        </p:nvSpPr>
+        <p:spPr>
+          <a:xfrm>
+            <a:off x="8183879" y="2267712"/>
+            <a:ext cx="73152" cy="1536192"/>
+          </a:xfrm>
+          <a:prstGeom prst="rect">
+            <a:avLst/>
+          </a:prstGeom>
+          <a:solidFill>
+            <a:srgbClr val="23847A"/>
+          </a:solidFill>
+          <a:ln>
+            <a:noFill/>
+          </a:ln>
+        </p:spPr>
+        <p:style>
+          <a:lnRef idx="1">
+            <a:schemeClr val="accent1"/>
+          </a:lnRef>
+          <a:fillRef idx="3">
+            <a:schemeClr val="accent1"/>
+          </a:fillRef>
+          <a:effectRef idx="2">
+            <a:schemeClr val="accent1"/>
+          </a:effectRef>
+          <a:fontRef idx="minor">
+            <a:schemeClr val="lt1"/>
+          </a:fontRef>
+        </p:style>
+        <p:txBody>
+          <a:bodyPr rtlCol="0" anchor="ctr"/>
+          <a:lstStyle/>
+          <a:p>
+            <a:pPr algn="ctr"/>
+          </a:p>
+        </p:txBody>
+      </p:sp>
+      <p:sp>
+        <p:nvSpPr>
+          <p:cNvPr id="25" name="TextBox 24"/>
+          <p:cNvSpPr txBox="1"/>
+          <p:nvPr/>
+        </p:nvSpPr>
+        <p:spPr>
+          <a:xfrm>
+            <a:off x="8385048" y="2432304"/>
+            <a:ext cx="2990088" cy="274320"/>
+          </a:xfrm>
+          <a:prstGeom prst="rect">
+            <a:avLst/>
+          </a:prstGeom>
+          <a:noFill/>
+        </p:spPr>
+        <p:txBody>
+          <a:bodyPr wrap="square">
+            <a:spAutoFit/>
+          </a:bodyPr>
+          <a:lstStyle/>
+          <a:p>
+            <a:pPr algn="l"/>
+            <a:r>
+              <a:rPr sz="1600" b="1">
+                <a:solidFill>
+                  <a:srgbClr val="0E162B"/>
+                </a:solidFill>
+                <a:latin typeface="Aptos"/>
+              </a:rPr>
+              <a:t>Evidence layer</a:t>
+            </a:r>
+          </a:p>
+        </p:txBody>
+      </p:sp>
+      <p:sp>
+        <p:nvSpPr>
+          <p:cNvPr id="26" name="TextBox 25"/>
+          <p:cNvSpPr txBox="1"/>
+          <p:nvPr/>
+        </p:nvSpPr>
+        <p:spPr>
+          <a:xfrm>
+            <a:off x="8385048" y="2798064"/>
+            <a:ext cx="2990088" cy="896112"/>
+          </a:xfrm>
+          <a:prstGeom prst="rect">
+            <a:avLst/>
+          </a:prstGeom>
+          <a:noFill/>
+        </p:spPr>
+        <p:txBody>
+          <a:bodyPr wrap="square">
+            <a:spAutoFit/>
+          </a:bodyPr>
+          <a:lstStyle/>
+          <a:p>
+            <a:pPr algn="l"/>
+            <a:r>
+              <a:rPr sz="1300" b="0">
+                <a:solidFill>
+                  <a:srgbClr val="465266"/>
+                </a:solidFill>
+                <a:latin typeface="Aptos"/>
+              </a:rPr>
+              <a:t>Held-out base/no-LoRA versus trained-LoRA scorecards, plots, public HF artifact repos, notebook, and a runnable Space.</a:t>
+            </a:r>
+          </a:p>
+        </p:txBody>
+      </p:sp>
+      <p:sp>
+        <p:nvSpPr>
+          <p:cNvPr id="27" name="Rounded Rectangle 26"/>
+          <p:cNvSpPr/>
+          <p:nvPr/>
+        </p:nvSpPr>
+        <p:spPr>
+          <a:xfrm>
+            <a:off x="1051560" y="4279392"/>
+            <a:ext cx="10149840" cy="1188720"/>
+          </a:xfrm>
+          <a:prstGeom prst="roundRect">
+            <a:avLst/>
+          </a:prstGeom>
+          <a:solidFill>
+            <a:srgbClr val="0E162B"/>
+          </a:solidFill>
+          <a:ln w="12700">
+            <a:solidFill>
+              <a:srgbClr val="E1E6EB"/>
+            </a:solidFill>
+          </a:ln>
+        </p:spPr>
+        <p:style>
+          <a:lnRef idx="1">
+            <a:schemeClr val="accent1"/>
+          </a:lnRef>
+          <a:fillRef idx="3">
+            <a:schemeClr val="accent1"/>
+          </a:fillRef>
+          <a:effectRef idx="2">
+            <a:schemeClr val="accent1"/>
+          </a:effectRef>
+          <a:fontRef idx="minor">
+            <a:schemeClr val="lt1"/>
+          </a:fontRef>
+        </p:style>
+        <p:txBody>
+          <a:bodyPr rtlCol="0" anchor="ctr"/>
+          <a:lstStyle/>
+          <a:p>
+            <a:pPr algn="ctr"/>
+          </a:p>
+        </p:txBody>
+      </p:sp>
+      <p:sp>
+        <p:nvSpPr>
+          <p:cNvPr id="28" name="Rectangle 27"/>
+          <p:cNvSpPr/>
+          <p:nvPr/>
+        </p:nvSpPr>
+        <p:spPr>
+          <a:xfrm>
+            <a:off x="1051560" y="4279392"/>
+            <a:ext cx="73152" cy="1188720"/>
+          </a:xfrm>
+          <a:prstGeom prst="rect">
+            <a:avLst/>
+          </a:prstGeom>
+          <a:solidFill>
+            <a:srgbClr val="EF7C3A"/>
+          </a:solidFill>
+          <a:ln>
+            <a:noFill/>
+          </a:ln>
+        </p:spPr>
+        <p:style>
+          <a:lnRef idx="1">
+            <a:schemeClr val="accent1"/>
+          </a:lnRef>
+          <a:fillRef idx="3">
+            <a:schemeClr val="accent1"/>
+          </a:fillRef>
+          <a:effectRef idx="2">
+            <a:schemeClr val="accent1"/>
+          </a:effectRef>
+          <a:fontRef idx="minor">
+            <a:schemeClr val="lt1"/>
+          </a:fontRef>
+        </p:style>
+        <p:txBody>
+          <a:bodyPr rtlCol="0" anchor="ctr"/>
+          <a:lstStyle/>
+          <a:p>
+            <a:pPr algn="ctr"/>
+          </a:p>
+        </p:txBody>
+      </p:sp>
+      <p:sp>
+        <p:nvSpPr>
+          <p:cNvPr id="29" name="TextBox 28"/>
+          <p:cNvSpPr txBox="1"/>
+          <p:nvPr/>
+        </p:nvSpPr>
+        <p:spPr>
+          <a:xfrm>
+            <a:off x="1252728" y="4443983"/>
+            <a:ext cx="9738360" cy="274320"/>
+          </a:xfrm>
+          <a:prstGeom prst="rect">
+            <a:avLst/>
+          </a:prstGeom>
+          <a:noFill/>
+        </p:spPr>
+        <p:txBody>
+          <a:bodyPr wrap="square">
+            <a:spAutoFit/>
+          </a:bodyPr>
+          <a:lstStyle/>
+          <a:p>
+            <a:pPr algn="l"/>
+            <a:r>
+              <a:rPr sz="1600" b="1">
+                <a:solidFill>
+                  <a:srgbClr val="0E162B"/>
+                </a:solidFill>
+                <a:latin typeface="Aptos"/>
+              </a:rPr>
+              <a:t>Design principle</a:t>
+            </a:r>
+          </a:p>
+        </p:txBody>
+      </p:sp>
+      <p:sp>
+        <p:nvSpPr>
+          <p:cNvPr id="30" name="TextBox 29"/>
+          <p:cNvSpPr txBox="1"/>
+          <p:nvPr/>
+        </p:nvSpPr>
+        <p:spPr>
+          <a:xfrm>
+            <a:off x="1252728" y="4809744"/>
+            <a:ext cx="9738360" cy="548640"/>
+          </a:xfrm>
+          <a:prstGeom prst="rect">
+            <a:avLst/>
+          </a:prstGeom>
+          <a:noFill/>
+        </p:spPr>
+        <p:txBody>
+          <a:bodyPr wrap="square">
+            <a:spAutoFit/>
+          </a:bodyPr>
+          <a:lstStyle/>
+          <a:p>
+            <a:pPr algn="l"/>
+            <a:r>
+              <a:rPr sz="1300" b="0">
+                <a:solidFill>
+                  <a:srgbClr val="465266"/>
+                </a:solidFill>
+                <a:latin typeface="Aptos"/>
+              </a:rPr>
+              <a:t>Keep the simulator legible, keep the model weights lightweight, and keep the evidence reproducible enough for a judge to rerun or inspect.</a:t>
+            </a:r>
+          </a:p>
+        </p:txBody>
+      </p:sp>
+      <p:sp>
+        <p:nvSpPr>
+          <p:cNvPr id="31" name="TextBox 30"/>
+          <p:cNvSpPr txBox="1"/>
+          <p:nvPr/>
+        </p:nvSpPr>
+        <p:spPr>
+          <a:xfrm>
+            <a:off x="1353312" y="4672584"/>
+            <a:ext cx="9509760" cy="347472"/>
+          </a:xfrm>
+          <a:prstGeom prst="rect">
+            <a:avLst/>
+          </a:prstGeom>
+          <a:noFill/>
+        </p:spPr>
+        <p:txBody>
+          <a:bodyPr wrap="square">
+            <a:spAutoFit/>
+          </a:bodyPr>
+          <a:lstStyle/>
+          <a:p>
+            <a:pPr algn="ctr"/>
+            <a:r>
+              <a:rPr sz="1900" b="1">
+                <a:solidFill>
+                  <a:srgbClr val="FFFFFF"/>
+                </a:solidFill>
+                <a:latin typeface="Georgia"/>
+              </a:rPr>
+              <a:t>This is why the project reads as a benchmark, not just a demo script.</a:t>
+            </a:r>
+          </a:p>
+        </p:txBody>
+      </p:sp>
+    </p:spTree>
+  </p:cSld>
+  <p:clrMapOvr>
+    <a:masterClrMapping/>
+  </p:clrMapOvr>
+</p:sld>
+</file>
+
+<file path=ppt/slides/slide14.xml><?xml version="1.0" encoding="utf-8"?>
+<p:sld xmlns:a="http://schemas.openxmlformats.org/drawingml/2006/main" xmlns:p="http://schemas.openxmlformats.org/presentationml/2006/main" xmlns:r="http://schemas.openxmlformats.org/officeDocument/2006/relationships">
+  <p:cSld>
+    <p:spTree>
+      <p:nvGrpSpPr>
+        <p:cNvPr id="1" name=""/>
+        <p:cNvGrpSpPr/>
+        <p:nvPr/>
+      </p:nvGrpSpPr>
+      <p:grpSpPr/>
+      <p:sp>
+        <p:nvSpPr>
+          <p:cNvPr id="2" name="Rectangle 1"/>
+          <p:cNvSpPr/>
+          <p:nvPr/>
+        </p:nvSpPr>
+        <p:spPr>
+          <a:xfrm>
+            <a:off x="0" y="0"/>
+            <a:ext cx="12191695" cy="6858000"/>
+          </a:xfrm>
+          <a:prstGeom prst="rect">
+            <a:avLst/>
+          </a:prstGeom>
+          <a:solidFill>
+            <a:srgbClr val="F8F4E8"/>
+          </a:solidFill>
+          <a:ln>
+            <a:noFill/>
+          </a:ln>
+        </p:spPr>
+        <p:style>
+          <a:lnRef idx="1">
+            <a:schemeClr val="accent1"/>
+          </a:lnRef>
+          <a:fillRef idx="3">
+            <a:schemeClr val="accent1"/>
+          </a:fillRef>
+          <a:effectRef idx="2">
+            <a:schemeClr val="accent1"/>
+          </a:effectRef>
+          <a:fontRef idx="minor">
+            <a:schemeClr val="lt1"/>
+          </a:fontRef>
+        </p:style>
+        <p:txBody>
+          <a:bodyPr rtlCol="0" anchor="ctr"/>
+          <a:lstStyle/>
+          <a:p>
+            <a:pPr algn="ctr"/>
+          </a:p>
+        </p:txBody>
+      </p:sp>
+      <p:sp>
+        <p:nvSpPr>
+          <p:cNvPr id="3" name="TextBox 2"/>
+          <p:cNvSpPr txBox="1"/>
+          <p:nvPr/>
+        </p:nvSpPr>
+        <p:spPr>
+          <a:xfrm>
+            <a:off x="594360" y="384048"/>
+            <a:ext cx="10972800" cy="457200"/>
+          </a:xfrm>
+          <a:prstGeom prst="rect">
+            <a:avLst/>
+          </a:prstGeom>
+          <a:noFill/>
+        </p:spPr>
+        <p:txBody>
+          <a:bodyPr wrap="square">
+            <a:spAutoFit/>
+          </a:bodyPr>
+          <a:lstStyle/>
+          <a:p>
+            <a:pPr algn="l"/>
+            <a:r>
+              <a:rPr sz="1500" b="1">
+                <a:solidFill>
+                  <a:srgbClr val="EF7C3A"/>
+                </a:solidFill>
+                <a:latin typeface="Aptos"/>
+              </a:rPr>
+              <a:t>WHY UNSLOTH?</a:t>
+            </a:r>
+          </a:p>
+        </p:txBody>
+      </p:sp>
+      <p:sp>
+        <p:nvSpPr>
+          <p:cNvPr id="4" name="TextBox 3"/>
+          <p:cNvSpPr txBox="1"/>
+          <p:nvPr/>
+        </p:nvSpPr>
+        <p:spPr>
+          <a:xfrm>
+            <a:off x="594360" y="804672"/>
+            <a:ext cx="10789920" cy="713232"/>
+          </a:xfrm>
+          <a:prstGeom prst="rect">
+            <a:avLst/>
+          </a:prstGeom>
+          <a:noFill/>
+        </p:spPr>
+        <p:txBody>
+          <a:bodyPr wrap="square">
+            <a:spAutoFit/>
+          </a:bodyPr>
+          <a:lstStyle/>
+          <a:p>
+            <a:pPr algn="l"/>
+            <a:r>
+              <a:rPr sz="3000" b="1">
+                <a:solidFill>
+                  <a:srgbClr val="0E162B"/>
+                </a:solidFill>
+                <a:latin typeface="Georgia"/>
+              </a:rPr>
+              <a:t>The training constraint was not glamour, it was throughput</a:t>
+            </a:r>
+          </a:p>
+        </p:txBody>
+      </p:sp>
+      <p:sp>
+        <p:nvSpPr>
+          <p:cNvPr id="5" name="Rounded Rectangle 4"/>
+          <p:cNvSpPr/>
+          <p:nvPr/>
+        </p:nvSpPr>
+        <p:spPr>
+          <a:xfrm>
+            <a:off x="731520" y="1755648"/>
+            <a:ext cx="3429000" cy="1298448"/>
+          </a:xfrm>
+          <a:prstGeom prst="roundRect">
+            <a:avLst/>
+          </a:prstGeom>
+          <a:solidFill>
+            <a:srgbClr val="FFFFFF"/>
+          </a:solidFill>
+          <a:ln w="12700">
+            <a:solidFill>
+              <a:srgbClr val="E1E6EB"/>
+            </a:solidFill>
+          </a:ln>
+        </p:spPr>
+        <p:style>
+          <a:lnRef idx="1">
+            <a:schemeClr val="accent1"/>
+          </a:lnRef>
+          <a:fillRef idx="3">
+            <a:schemeClr val="accent1"/>
+          </a:fillRef>
+          <a:effectRef idx="2">
+            <a:schemeClr val="accent1"/>
+          </a:effectRef>
+          <a:fontRef idx="minor">
+            <a:schemeClr val="lt1"/>
+          </a:fontRef>
+        </p:style>
+        <p:txBody>
+          <a:bodyPr rtlCol="0" anchor="ctr"/>
+          <a:lstStyle/>
+          <a:p>
+            <a:pPr algn="ctr"/>
+          </a:p>
+        </p:txBody>
+      </p:sp>
+      <p:sp>
+        <p:nvSpPr>
+          <p:cNvPr id="6" name="Rectangle 5"/>
+          <p:cNvSpPr/>
+          <p:nvPr/>
+        </p:nvSpPr>
+        <p:spPr>
+          <a:xfrm>
+            <a:off x="731520" y="1755648"/>
+            <a:ext cx="73152" cy="1298448"/>
+          </a:xfrm>
+          <a:prstGeom prst="rect">
+            <a:avLst/>
+          </a:prstGeom>
+          <a:solidFill>
+            <a:srgbClr val="23847A"/>
+          </a:solidFill>
+          <a:ln>
+            <a:noFill/>
+          </a:ln>
+        </p:spPr>
+        <p:style>
+          <a:lnRef idx="1">
+            <a:schemeClr val="accent1"/>
+          </a:lnRef>
+          <a:fillRef idx="3">
+            <a:schemeClr val="accent1"/>
+          </a:fillRef>
+          <a:effectRef idx="2">
+            <a:schemeClr val="accent1"/>
+          </a:effectRef>
+          <a:fontRef idx="minor">
+            <a:schemeClr val="lt1"/>
+          </a:fontRef>
+        </p:style>
+        <p:txBody>
+          <a:bodyPr rtlCol="0" anchor="ctr"/>
+          <a:lstStyle/>
+          <a:p>
+            <a:pPr algn="ctr"/>
+          </a:p>
+        </p:txBody>
+      </p:sp>
+      <p:sp>
+        <p:nvSpPr>
+          <p:cNvPr id="7" name="TextBox 6"/>
+          <p:cNvSpPr txBox="1"/>
+          <p:nvPr/>
+        </p:nvSpPr>
+        <p:spPr>
+          <a:xfrm>
+            <a:off x="932688" y="1920240"/>
+            <a:ext cx="3017520" cy="274320"/>
+          </a:xfrm>
+          <a:prstGeom prst="rect">
+            <a:avLst/>
+          </a:prstGeom>
+          <a:noFill/>
+        </p:spPr>
+        <p:txBody>
+          <a:bodyPr wrap="square">
+            <a:spAutoFit/>
+          </a:bodyPr>
+          <a:lstStyle/>
+          <a:p>
+            <a:pPr algn="l"/>
+            <a:r>
+              <a:rPr sz="1600" b="1">
+                <a:solidFill>
+                  <a:srgbClr val="0E162B"/>
+                </a:solidFill>
+                <a:latin typeface="Aptos"/>
+              </a:rPr>
+              <a:t>Lower memory pressure</a:t>
+            </a:r>
+          </a:p>
+        </p:txBody>
+      </p:sp>
+      <p:sp>
+        <p:nvSpPr>
+          <p:cNvPr id="8" name="TextBox 7"/>
+          <p:cNvSpPr txBox="1"/>
+          <p:nvPr/>
+        </p:nvSpPr>
+        <p:spPr>
+          <a:xfrm>
+            <a:off x="932688" y="2286000"/>
+            <a:ext cx="3017520" cy="658368"/>
+          </a:xfrm>
+          <a:prstGeom prst="rect">
+            <a:avLst/>
+          </a:prstGeom>
+          <a:noFill/>
+        </p:spPr>
+        <p:txBody>
+          <a:bodyPr wrap="square">
+            <a:spAutoFit/>
+          </a:bodyPr>
+          <a:lstStyle/>
+          <a:p>
+            <a:pPr algn="l"/>
+            <a:r>
+              <a:rPr sz="1300" b="0">
+                <a:solidFill>
+                  <a:srgbClr val="465266"/>
+                </a:solidFill>
+                <a:latin typeface="Aptos"/>
+              </a:rPr>
+              <a:t>The base model is loaded in 4-bit mode, which made 3B specialists and 7B orchestration experiments practical on rented GPUs.</a:t>
+            </a:r>
+          </a:p>
+        </p:txBody>
+      </p:sp>
+      <p:sp>
+        <p:nvSpPr>
+          <p:cNvPr id="9" name="Rounded Rectangle 8"/>
+          <p:cNvSpPr/>
+          <p:nvPr/>
+        </p:nvSpPr>
+        <p:spPr>
+          <a:xfrm>
+            <a:off x="4407408" y="1755648"/>
+            <a:ext cx="3429000" cy="1298448"/>
+          </a:xfrm>
+          <a:prstGeom prst="roundRect">
+            <a:avLst/>
+          </a:prstGeom>
+          <a:solidFill>
+            <a:srgbClr val="FFFFFF"/>
+          </a:solidFill>
+          <a:ln w="12700">
+            <a:solidFill>
+              <a:srgbClr val="E1E6EB"/>
+            </a:solidFill>
+          </a:ln>
+        </p:spPr>
+        <p:style>
+          <a:lnRef idx="1">
+            <a:schemeClr val="accent1"/>
+          </a:lnRef>
+          <a:fillRef idx="3">
+            <a:schemeClr val="accent1"/>
+          </a:fillRef>
+          <a:effectRef idx="2">
+            <a:schemeClr val="accent1"/>
+          </a:effectRef>
+          <a:fontRef idx="minor">
+            <a:schemeClr val="lt1"/>
+          </a:fontRef>
+        </p:style>
+        <p:txBody>
+          <a:bodyPr rtlCol="0" anchor="ctr"/>
+          <a:lstStyle/>
+          <a:p>
+            <a:pPr algn="ctr"/>
+          </a:p>
+        </p:txBody>
+      </p:sp>
+      <p:sp>
+        <p:nvSpPr>
+          <p:cNvPr id="10" name="Rectangle 9"/>
+          <p:cNvSpPr/>
+          <p:nvPr/>
+        </p:nvSpPr>
+        <p:spPr>
+          <a:xfrm>
+            <a:off x="4407408" y="1755648"/>
+            <a:ext cx="73152" cy="1298448"/>
+          </a:xfrm>
+          <a:prstGeom prst="rect">
+            <a:avLst/>
+          </a:prstGeom>
+          <a:solidFill>
+            <a:srgbClr val="EF7C3A"/>
+          </a:solidFill>
+          <a:ln>
+            <a:noFill/>
+          </a:ln>
+        </p:spPr>
+        <p:style>
+          <a:lnRef idx="1">
+            <a:schemeClr val="accent1"/>
+          </a:lnRef>
+          <a:fillRef idx="3">
+            <a:schemeClr val="accent1"/>
+          </a:fillRef>
+          <a:effectRef idx="2">
+            <a:schemeClr val="accent1"/>
+          </a:effectRef>
+          <a:fontRef idx="minor">
+            <a:schemeClr val="lt1"/>
+          </a:fontRef>
+        </p:style>
+        <p:txBody>
+          <a:bodyPr rtlCol="0" anchor="ctr"/>
+          <a:lstStyle/>
+          <a:p>
+            <a:pPr algn="ctr"/>
+          </a:p>
+        </p:txBody>
+      </p:sp>
+      <p:sp>
+        <p:nvSpPr>
+          <p:cNvPr id="11" name="TextBox 10"/>
+          <p:cNvSpPr txBox="1"/>
+          <p:nvPr/>
+        </p:nvSpPr>
+        <p:spPr>
+          <a:xfrm>
+            <a:off x="4608576" y="1920240"/>
+            <a:ext cx="3017520" cy="274320"/>
+          </a:xfrm>
+          <a:prstGeom prst="rect">
+            <a:avLst/>
+          </a:prstGeom>
+          <a:noFill/>
+        </p:spPr>
+        <p:txBody>
+          <a:bodyPr wrap="square">
+            <a:spAutoFit/>
+          </a:bodyPr>
+          <a:lstStyle/>
+          <a:p>
+            <a:pPr algn="l"/>
+            <a:r>
+              <a:rPr sz="1600" b="1">
+                <a:solidFill>
+                  <a:srgbClr val="0E162B"/>
+                </a:solidFill>
+                <a:latin typeface="Aptos"/>
+              </a:rPr>
+              <a:t>Fast adapter iteration</a:t>
+            </a:r>
+          </a:p>
+        </p:txBody>
+      </p:sp>
+      <p:sp>
+        <p:nvSpPr>
+          <p:cNvPr id="12" name="TextBox 11"/>
+          <p:cNvSpPr txBox="1"/>
+          <p:nvPr/>
+        </p:nvSpPr>
+        <p:spPr>
+          <a:xfrm>
+            <a:off x="4608576" y="2286000"/>
+            <a:ext cx="3017520" cy="658368"/>
+          </a:xfrm>
+          <a:prstGeom prst="rect">
+            <a:avLst/>
+          </a:prstGeom>
+          <a:noFill/>
+        </p:spPr>
+        <p:txBody>
+          <a:bodyPr wrap="square">
+            <a:spAutoFit/>
+          </a:bodyPr>
+          <a:lstStyle/>
+          <a:p>
+            <a:pPr algn="l"/>
+            <a:r>
+              <a:rPr sz="1300" b="0">
+                <a:solidFill>
+                  <a:srgbClr val="465266"/>
+                </a:solidFill>
+                <a:latin typeface="Aptos"/>
+              </a:rPr>
+              <a:t>We needed frequent short runs, parser fixes, resume tests, and canaries. Adapter-only training kept iteration speed sane.</a:t>
+            </a:r>
+          </a:p>
+        </p:txBody>
+      </p:sp>
+      <p:sp>
+        <p:nvSpPr>
+          <p:cNvPr id="13" name="Rounded Rectangle 12"/>
+          <p:cNvSpPr/>
+          <p:nvPr/>
+        </p:nvSpPr>
+        <p:spPr>
+          <a:xfrm>
+            <a:off x="8083296" y="1755648"/>
+            <a:ext cx="3429000" cy="1298448"/>
+          </a:xfrm>
+          <a:prstGeom prst="roundRect">
+            <a:avLst/>
+          </a:prstGeom>
+          <a:solidFill>
+            <a:srgbClr val="FFFFFF"/>
+          </a:solidFill>
+          <a:ln w="12700">
+            <a:solidFill>
+              <a:srgbClr val="E1E6EB"/>
+            </a:solidFill>
+          </a:ln>
+        </p:spPr>
+        <p:style>
+          <a:lnRef idx="1">
+            <a:schemeClr val="accent1"/>
+          </a:lnRef>
+          <a:fillRef idx="3">
+            <a:schemeClr val="accent1"/>
+          </a:fillRef>
+          <a:effectRef idx="2">
+            <a:schemeClr val="accent1"/>
+          </a:effectRef>
+          <a:fontRef idx="minor">
+            <a:schemeClr val="lt1"/>
+          </a:fontRef>
+        </p:style>
+        <p:txBody>
+          <a:bodyPr rtlCol="0" anchor="ctr"/>
+          <a:lstStyle/>
+          <a:p>
+            <a:pPr algn="ctr"/>
+          </a:p>
+        </p:txBody>
+      </p:sp>
+      <p:sp>
+        <p:nvSpPr>
+          <p:cNvPr id="14" name="Rectangle 13"/>
+          <p:cNvSpPr/>
+          <p:nvPr/>
+        </p:nvSpPr>
+        <p:spPr>
+          <a:xfrm>
+            <a:off x="8083296" y="1755648"/>
+            <a:ext cx="73152" cy="1298448"/>
+          </a:xfrm>
+          <a:prstGeom prst="rect">
+            <a:avLst/>
+          </a:prstGeom>
+          <a:solidFill>
+            <a:srgbClr val="23847A"/>
+          </a:solidFill>
+          <a:ln>
+            <a:noFill/>
+          </a:ln>
+        </p:spPr>
+        <p:style>
+          <a:lnRef idx="1">
+            <a:schemeClr val="accent1"/>
+          </a:lnRef>
+          <a:fillRef idx="3">
+            <a:schemeClr val="accent1"/>
+          </a:fillRef>
+          <a:effectRef idx="2">
+            <a:schemeClr val="accent1"/>
+          </a:effectRef>
+          <a:fontRef idx="minor">
+            <a:schemeClr val="lt1"/>
+          </a:fontRef>
+        </p:style>
+        <p:txBody>
+          <a:bodyPr rtlCol="0" anchor="ctr"/>
+          <a:lstStyle/>
+          <a:p>
+            <a:pPr algn="ctr"/>
+          </a:p>
+        </p:txBody>
+      </p:sp>
+      <p:sp>
+        <p:nvSpPr>
+          <p:cNvPr id="15" name="TextBox 14"/>
+          <p:cNvSpPr txBox="1"/>
+          <p:nvPr/>
+        </p:nvSpPr>
+        <p:spPr>
+          <a:xfrm>
+            <a:off x="8284464" y="1920240"/>
+            <a:ext cx="3017520" cy="274320"/>
+          </a:xfrm>
+          <a:prstGeom prst="rect">
+            <a:avLst/>
+          </a:prstGeom>
+          <a:noFill/>
+        </p:spPr>
+        <p:txBody>
+          <a:bodyPr wrap="square">
+            <a:spAutoFit/>
+          </a:bodyPr>
+          <a:lstStyle/>
+          <a:p>
+            <a:pPr algn="l"/>
+            <a:r>
+              <a:rPr sz="1600" b="1">
+                <a:solidFill>
+                  <a:srgbClr val="0E162B"/>
+                </a:solidFill>
+                <a:latin typeface="Aptos"/>
+              </a:rPr>
+              <a:t>Qwen-friendly path</a:t>
+            </a:r>
+          </a:p>
+        </p:txBody>
+      </p:sp>
+      <p:sp>
+        <p:nvSpPr>
+          <p:cNvPr id="16" name="TextBox 15"/>
+          <p:cNvSpPr txBox="1"/>
+          <p:nvPr/>
+        </p:nvSpPr>
+        <p:spPr>
+          <a:xfrm>
+            <a:off x="8284464" y="2286000"/>
+            <a:ext cx="3017520" cy="658368"/>
+          </a:xfrm>
+          <a:prstGeom prst="rect">
+            <a:avLst/>
+          </a:prstGeom>
+          <a:noFill/>
+        </p:spPr>
+        <p:txBody>
+          <a:bodyPr wrap="square">
+            <a:spAutoFit/>
+          </a:bodyPr>
+          <a:lstStyle/>
+          <a:p>
+            <a:pPr algn="l"/>
+            <a:r>
+              <a:rPr sz="1300" b="0">
+                <a:solidFill>
+                  <a:srgbClr val="465266"/>
+                </a:solidFill>
+                <a:latin typeface="Aptos"/>
+              </a:rPr>
+              <a:t>The stack supports the Qwen2.5 Instruct family used for the 3B floor specialists and the 7B orchestrator lane.</a:t>
+            </a:r>
+          </a:p>
+        </p:txBody>
+      </p:sp>
+      <p:sp>
+        <p:nvSpPr>
+          <p:cNvPr id="17" name="Rounded Rectangle 16"/>
+          <p:cNvSpPr/>
+          <p:nvPr/>
+        </p:nvSpPr>
+        <p:spPr>
+          <a:xfrm>
+            <a:off x="1143000" y="3520440"/>
+            <a:ext cx="4800600" cy="1298448"/>
+          </a:xfrm>
+          <a:prstGeom prst="roundRect">
+            <a:avLst/>
+          </a:prstGeom>
+          <a:solidFill>
+            <a:srgbClr val="FFFFFF"/>
+          </a:solidFill>
+          <a:ln w="12700">
+            <a:solidFill>
+              <a:srgbClr val="E1E6EB"/>
+            </a:solidFill>
+          </a:ln>
+        </p:spPr>
+        <p:style>
+          <a:lnRef idx="1">
+            <a:schemeClr val="accent1"/>
+          </a:lnRef>
+          <a:fillRef idx="3">
+            <a:schemeClr val="accent1"/>
+          </a:fillRef>
+          <a:effectRef idx="2">
+            <a:schemeClr val="accent1"/>
+          </a:effectRef>
+          <a:fontRef idx="minor">
+            <a:schemeClr val="lt1"/>
+          </a:fontRef>
+        </p:style>
+        <p:txBody>
+          <a:bodyPr rtlCol="0" anchor="ctr"/>
+          <a:lstStyle/>
+          <a:p>
+            <a:pPr algn="ctr"/>
+          </a:p>
+        </p:txBody>
+      </p:sp>
+      <p:sp>
+        <p:nvSpPr>
+          <p:cNvPr id="18" name="Rectangle 17"/>
+          <p:cNvSpPr/>
+          <p:nvPr/>
+        </p:nvSpPr>
+        <p:spPr>
+          <a:xfrm>
+            <a:off x="1143000" y="3520440"/>
+            <a:ext cx="73152" cy="1298448"/>
+          </a:xfrm>
+          <a:prstGeom prst="rect">
+            <a:avLst/>
+          </a:prstGeom>
+          <a:solidFill>
+            <a:srgbClr val="EF7C3A"/>
+          </a:solidFill>
+          <a:ln>
+            <a:noFill/>
+          </a:ln>
+        </p:spPr>
+        <p:style>
+          <a:lnRef idx="1">
+            <a:schemeClr val="accent1"/>
+          </a:lnRef>
+          <a:fillRef idx="3">
+            <a:schemeClr val="accent1"/>
+          </a:fillRef>
+          <a:effectRef idx="2">
+            <a:schemeClr val="accent1"/>
+          </a:effectRef>
+          <a:fontRef idx="minor">
+            <a:schemeClr val="lt1"/>
+          </a:fontRef>
+        </p:style>
+        <p:txBody>
+          <a:bodyPr rtlCol="0" anchor="ctr"/>
+          <a:lstStyle/>
+          <a:p>
+            <a:pPr algn="ctr"/>
+          </a:p>
+        </p:txBody>
+      </p:sp>
+      <p:sp>
+        <p:nvSpPr>
+          <p:cNvPr id="19" name="TextBox 18"/>
+          <p:cNvSpPr txBox="1"/>
+          <p:nvPr/>
+        </p:nvSpPr>
+        <p:spPr>
+          <a:xfrm>
+            <a:off x="1344168" y="3685032"/>
+            <a:ext cx="4389120" cy="274320"/>
+          </a:xfrm>
+          <a:prstGeom prst="rect">
+            <a:avLst/>
+          </a:prstGeom>
+          <a:noFill/>
+        </p:spPr>
+        <p:txBody>
+          <a:bodyPr wrap="square">
+            <a:spAutoFit/>
+          </a:bodyPr>
+          <a:lstStyle/>
+          <a:p>
+            <a:pPr algn="l"/>
+            <a:r>
+              <a:rPr sz="1600" b="1">
+                <a:solidFill>
+                  <a:srgbClr val="0E162B"/>
+                </a:solidFill>
+                <a:latin typeface="Aptos"/>
+              </a:rPr>
+              <a:t>Checkpoint economics</a:t>
+            </a:r>
+          </a:p>
+        </p:txBody>
+      </p:sp>
+      <p:sp>
+        <p:nvSpPr>
+          <p:cNvPr id="20" name="TextBox 19"/>
+          <p:cNvSpPr txBox="1"/>
+          <p:nvPr/>
+        </p:nvSpPr>
+        <p:spPr>
+          <a:xfrm>
+            <a:off x="1344168" y="4050791"/>
+            <a:ext cx="4389120" cy="658368"/>
+          </a:xfrm>
+          <a:prstGeom prst="rect">
+            <a:avLst/>
+          </a:prstGeom>
+          <a:noFill/>
+        </p:spPr>
+        <p:txBody>
+          <a:bodyPr wrap="square">
+            <a:spAutoFit/>
+          </a:bodyPr>
+          <a:lstStyle/>
+          <a:p>
+            <a:pPr algn="l"/>
+            <a:r>
+              <a:rPr sz="1300" b="0">
+                <a:solidFill>
+                  <a:srgbClr val="465266"/>
+                </a:solidFill>
+                <a:latin typeface="Aptos"/>
+              </a:rPr>
+              <a:t>Uploading full model copies for every specialist would be wasteful. LoRA adapter folders are smaller, clearer, and easier to compare.</a:t>
+            </a:r>
+          </a:p>
+        </p:txBody>
+      </p:sp>
+      <p:sp>
+        <p:nvSpPr>
+          <p:cNvPr id="21" name="Rounded Rectangle 20"/>
+          <p:cNvSpPr/>
+          <p:nvPr/>
+        </p:nvSpPr>
+        <p:spPr>
+          <a:xfrm>
+            <a:off x="6263640" y="3520440"/>
+            <a:ext cx="4800600" cy="1298448"/>
+          </a:xfrm>
+          <a:prstGeom prst="roundRect">
+            <a:avLst/>
+          </a:prstGeom>
+          <a:solidFill>
+            <a:srgbClr val="FFFFFF"/>
+          </a:solidFill>
+          <a:ln w="12700">
+            <a:solidFill>
+              <a:srgbClr val="E1E6EB"/>
+            </a:solidFill>
+          </a:ln>
+        </p:spPr>
+        <p:style>
+          <a:lnRef idx="1">
+            <a:schemeClr val="accent1"/>
+          </a:lnRef>
+          <a:fillRef idx="3">
+            <a:schemeClr val="accent1"/>
+          </a:fillRef>
+          <a:effectRef idx="2">
+            <a:schemeClr val="accent1"/>
+          </a:effectRef>
+          <a:fontRef idx="minor">
+            <a:schemeClr val="lt1"/>
+          </a:fontRef>
+        </p:style>
+        <p:txBody>
+          <a:bodyPr rtlCol="0" anchor="ctr"/>
+          <a:lstStyle/>
+          <a:p>
+            <a:pPr algn="ctr"/>
+          </a:p>
+        </p:txBody>
+      </p:sp>
+      <p:sp>
+        <p:nvSpPr>
+          <p:cNvPr id="22" name="Rectangle 21"/>
+          <p:cNvSpPr/>
+          <p:nvPr/>
+        </p:nvSpPr>
+        <p:spPr>
+          <a:xfrm>
+            <a:off x="6263640" y="3520440"/>
+            <a:ext cx="73152" cy="1298448"/>
+          </a:xfrm>
+          <a:prstGeom prst="rect">
+            <a:avLst/>
+          </a:prstGeom>
+          <a:solidFill>
+            <a:srgbClr val="23847A"/>
+          </a:solidFill>
+          <a:ln>
+            <a:noFill/>
+          </a:ln>
+        </p:spPr>
+        <p:style>
+          <a:lnRef idx="1">
+            <a:schemeClr val="accent1"/>
+          </a:lnRef>
+          <a:fillRef idx="3">
+            <a:schemeClr val="accent1"/>
+          </a:fillRef>
+          <a:effectRef idx="2">
+            <a:schemeClr val="accent1"/>
+          </a:effectRef>
+          <a:fontRef idx="minor">
+            <a:schemeClr val="lt1"/>
+          </a:fontRef>
+        </p:style>
+        <p:txBody>
+          <a:bodyPr rtlCol="0" anchor="ctr"/>
+          <a:lstStyle/>
+          <a:p>
+            <a:pPr algn="ctr"/>
+          </a:p>
+        </p:txBody>
+      </p:sp>
+      <p:sp>
+        <p:nvSpPr>
+          <p:cNvPr id="23" name="TextBox 22"/>
+          <p:cNvSpPr txBox="1"/>
+          <p:nvPr/>
+        </p:nvSpPr>
+        <p:spPr>
+          <a:xfrm>
+            <a:off x="6464807" y="3685032"/>
+            <a:ext cx="4389120" cy="274320"/>
+          </a:xfrm>
+          <a:prstGeom prst="rect">
+            <a:avLst/>
+          </a:prstGeom>
+          <a:noFill/>
+        </p:spPr>
+        <p:txBody>
+          <a:bodyPr wrap="square">
+            <a:spAutoFit/>
+          </a:bodyPr>
+          <a:lstStyle/>
+          <a:p>
+            <a:pPr algn="l"/>
+            <a:r>
+              <a:rPr sz="1600" b="1">
+                <a:solidFill>
+                  <a:srgbClr val="0E162B"/>
+                </a:solidFill>
+                <a:latin typeface="Aptos"/>
+              </a:rPr>
+              <a:t>Failure recovery</a:t>
+            </a:r>
+          </a:p>
+        </p:txBody>
+      </p:sp>
+      <p:sp>
+        <p:nvSpPr>
+          <p:cNvPr id="24" name="TextBox 23"/>
+          <p:cNvSpPr txBox="1"/>
+          <p:nvPr/>
+        </p:nvSpPr>
+        <p:spPr>
+          <a:xfrm>
+            <a:off x="6464807" y="4050791"/>
+            <a:ext cx="4389120" cy="658368"/>
+          </a:xfrm>
+          <a:prstGeom prst="rect">
+            <a:avLst/>
+          </a:prstGeom>
+          <a:noFill/>
+        </p:spPr>
+        <p:txBody>
+          <a:bodyPr wrap="square">
+            <a:spAutoFit/>
+          </a:bodyPr>
+          <a:lstStyle/>
+          <a:p>
+            <a:pPr algn="l"/>
+            <a:r>
+              <a:rPr sz="1300" b="0">
+                <a:solidFill>
+                  <a:srgbClr val="465266"/>
+                </a:solidFill>
+                <a:latin typeface="Aptos"/>
+              </a:rPr>
+              <a:t>When CUDA, parser, or reward issues appeared, we could resume from checkpoints instead of restarting every experiment from zero.</a:t>
+            </a:r>
+          </a:p>
+        </p:txBody>
+      </p:sp>
+      <p:sp>
+        <p:nvSpPr>
+          <p:cNvPr id="25" name="TextBox 24"/>
+          <p:cNvSpPr txBox="1"/>
+          <p:nvPr/>
+        </p:nvSpPr>
+        <p:spPr>
+          <a:xfrm>
+            <a:off x="914400" y="5349240"/>
+            <a:ext cx="10378440" cy="310896"/>
+          </a:xfrm>
+          <a:prstGeom prst="rect">
+            <a:avLst/>
+          </a:prstGeom>
+          <a:noFill/>
+        </p:spPr>
+        <p:txBody>
+          <a:bodyPr wrap="square">
+            <a:spAutoFit/>
+          </a:bodyPr>
+          <a:lstStyle/>
+          <a:p>
+            <a:pPr algn="ctr"/>
+            <a:r>
+              <a:rPr sz="1800" b="1">
+                <a:solidFill>
+                  <a:srgbClr val="0E162B"/>
+                </a:solidFill>
+                <a:latin typeface="Georgia"/>
+              </a:rPr>
+              <a:t>In short: Unsloth let us spend compute on environment interaction instead of on moving huge model copies around.</a:t>
+            </a:r>
+          </a:p>
+        </p:txBody>
+      </p:sp>
+    </p:spTree>
+  </p:cSld>
+  <p:clrMapOvr>
+    <a:masterClrMapping/>
+  </p:clrMapOvr>
+</p:sld>
+</file>
+
+<file path=ppt/slides/slide15.xml><?xml version="1.0" encoding="utf-8"?>
+<p:sld xmlns:a="http://schemas.openxmlformats.org/drawingml/2006/main" xmlns:p="http://schemas.openxmlformats.org/presentationml/2006/main" xmlns:r="http://schemas.openxmlformats.org/officeDocument/2006/relationships">
+  <p:cSld>
+    <p:spTree>
+      <p:nvGrpSpPr>
+        <p:cNvPr id="1" name=""/>
+        <p:cNvGrpSpPr/>
+        <p:nvPr/>
+      </p:nvGrpSpPr>
+      <p:grpSpPr/>
+      <p:sp>
+        <p:nvSpPr>
+          <p:cNvPr id="2" name="Rectangle 1"/>
+          <p:cNvSpPr/>
+          <p:nvPr/>
+        </p:nvSpPr>
+        <p:spPr>
+          <a:xfrm>
+            <a:off x="0" y="0"/>
+            <a:ext cx="12191695" cy="6858000"/>
+          </a:xfrm>
+          <a:prstGeom prst="rect">
+            <a:avLst/>
+          </a:prstGeom>
+          <a:solidFill>
+            <a:srgbClr val="F8F4E8"/>
+          </a:solidFill>
+          <a:ln>
+            <a:noFill/>
+          </a:ln>
+        </p:spPr>
+        <p:style>
+          <a:lnRef idx="1">
+            <a:schemeClr val="accent1"/>
+          </a:lnRef>
+          <a:fillRef idx="3">
+            <a:schemeClr val="accent1"/>
+          </a:fillRef>
+          <a:effectRef idx="2">
+            <a:schemeClr val="accent1"/>
+          </a:effectRef>
+          <a:fontRef idx="minor">
+            <a:schemeClr val="lt1"/>
+          </a:fontRef>
+        </p:style>
+        <p:txBody>
+          <a:bodyPr rtlCol="0" anchor="ctr"/>
+          <a:lstStyle/>
+          <a:p>
+            <a:pPr algn="ctr"/>
+          </a:p>
+        </p:txBody>
+      </p:sp>
+      <p:sp>
+        <p:nvSpPr>
+          <p:cNvPr id="3" name="TextBox 2"/>
+          <p:cNvSpPr txBox="1"/>
+          <p:nvPr/>
+        </p:nvSpPr>
+        <p:spPr>
+          <a:xfrm>
+            <a:off x="594360" y="384048"/>
+            <a:ext cx="10972800" cy="457200"/>
+          </a:xfrm>
+          <a:prstGeom prst="rect">
+            <a:avLst/>
+          </a:prstGeom>
+          <a:noFill/>
+        </p:spPr>
+        <p:txBody>
+          <a:bodyPr wrap="square">
+            <a:spAutoFit/>
+          </a:bodyPr>
+          <a:lstStyle/>
+          <a:p>
+            <a:pPr algn="l"/>
+            <a:r>
+              <a:rPr sz="1500" b="1">
+                <a:solidFill>
+                  <a:srgbClr val="EF7C3A"/>
+                </a:solidFill>
+                <a:latin typeface="Aptos"/>
+              </a:rPr>
+              <a:t>LORA VS QLORA</a:t>
+            </a:r>
+          </a:p>
+        </p:txBody>
+      </p:sp>
+      <p:sp>
+        <p:nvSpPr>
+          <p:cNvPr id="4" name="TextBox 3"/>
+          <p:cNvSpPr txBox="1"/>
+          <p:nvPr/>
+        </p:nvSpPr>
+        <p:spPr>
+          <a:xfrm>
+            <a:off x="594360" y="804672"/>
+            <a:ext cx="10789920" cy="713232"/>
+          </a:xfrm>
+          <a:prstGeom prst="rect">
+            <a:avLst/>
+          </a:prstGeom>
+          <a:noFill/>
+        </p:spPr>
+        <p:txBody>
+          <a:bodyPr wrap="square">
+            <a:spAutoFit/>
+          </a:bodyPr>
+          <a:lstStyle/>
+          <a:p>
+            <a:pPr algn="l"/>
+            <a:r>
+              <a:rPr sz="3000" b="1">
+                <a:solidFill>
+                  <a:srgbClr val="0E162B"/>
+                </a:solidFill>
+                <a:latin typeface="Georgia"/>
+              </a:rPr>
+              <a:t>What we used, and why the wording matters</a:t>
+            </a:r>
+          </a:p>
+        </p:txBody>
+      </p:sp>
+      <p:sp>
+        <p:nvSpPr>
+          <p:cNvPr id="5" name="Rounded Rectangle 4"/>
+          <p:cNvSpPr/>
+          <p:nvPr/>
+        </p:nvSpPr>
+        <p:spPr>
+          <a:xfrm>
+            <a:off x="685800" y="1691640"/>
+            <a:ext cx="3429000" cy="2148840"/>
+          </a:xfrm>
+          <a:prstGeom prst="roundRect">
+            <a:avLst/>
+          </a:prstGeom>
+          <a:solidFill>
+            <a:srgbClr val="FFFFFF"/>
+          </a:solidFill>
+          <a:ln w="12700">
+            <a:solidFill>
+              <a:srgbClr val="E1E6EB"/>
+            </a:solidFill>
+          </a:ln>
+        </p:spPr>
+        <p:style>
+          <a:lnRef idx="1">
+            <a:schemeClr val="accent1"/>
+          </a:lnRef>
+          <a:fillRef idx="3">
+            <a:schemeClr val="accent1"/>
+          </a:fillRef>
+          <a:effectRef idx="2">
+            <a:schemeClr val="accent1"/>
+          </a:effectRef>
+          <a:fontRef idx="minor">
+            <a:schemeClr val="lt1"/>
+          </a:fontRef>
+        </p:style>
+        <p:txBody>
+          <a:bodyPr rtlCol="0" anchor="ctr"/>
+          <a:lstStyle/>
+          <a:p>
+            <a:pPr algn="ctr"/>
+          </a:p>
+        </p:txBody>
+      </p:sp>
+      <p:sp>
+        <p:nvSpPr>
+          <p:cNvPr id="6" name="Rectangle 5"/>
+          <p:cNvSpPr/>
+          <p:nvPr/>
+        </p:nvSpPr>
+        <p:spPr>
+          <a:xfrm>
+            <a:off x="685800" y="1691640"/>
+            <a:ext cx="73152" cy="2148840"/>
+          </a:xfrm>
+          <a:prstGeom prst="rect">
+            <a:avLst/>
+          </a:prstGeom>
+          <a:solidFill>
+            <a:srgbClr val="23847A"/>
+          </a:solidFill>
+          <a:ln>
+            <a:noFill/>
+          </a:ln>
+        </p:spPr>
+        <p:style>
+          <a:lnRef idx="1">
+            <a:schemeClr val="accent1"/>
+          </a:lnRef>
+          <a:fillRef idx="3">
+            <a:schemeClr val="accent1"/>
+          </a:fillRef>
+          <a:effectRef idx="2">
+            <a:schemeClr val="accent1"/>
+          </a:effectRef>
+          <a:fontRef idx="minor">
+            <a:schemeClr val="lt1"/>
+          </a:fontRef>
+        </p:style>
+        <p:txBody>
+          <a:bodyPr rtlCol="0" anchor="ctr"/>
+          <a:lstStyle/>
+          <a:p>
+            <a:pPr algn="ctr"/>
+          </a:p>
+        </p:txBody>
+      </p:sp>
+      <p:sp>
+        <p:nvSpPr>
+          <p:cNvPr id="7" name="TextBox 6"/>
+          <p:cNvSpPr txBox="1"/>
+          <p:nvPr/>
+        </p:nvSpPr>
+        <p:spPr>
+          <a:xfrm>
+            <a:off x="886968" y="1856232"/>
+            <a:ext cx="3017520" cy="274320"/>
+          </a:xfrm>
+          <a:prstGeom prst="rect">
+            <a:avLst/>
+          </a:prstGeom>
+          <a:noFill/>
+        </p:spPr>
+        <p:txBody>
+          <a:bodyPr wrap="square">
+            <a:spAutoFit/>
+          </a:bodyPr>
+          <a:lstStyle/>
+          <a:p>
+            <a:pPr algn="l"/>
+            <a:r>
+              <a:rPr sz="1600" b="1">
+                <a:solidFill>
+                  <a:srgbClr val="0E162B"/>
+                </a:solidFill>
+                <a:latin typeface="Aptos"/>
+              </a:rPr>
+              <a:t>LoRA</a:t>
+            </a:r>
+          </a:p>
+        </p:txBody>
+      </p:sp>
+      <p:sp>
+        <p:nvSpPr>
+          <p:cNvPr id="8" name="TextBox 7"/>
+          <p:cNvSpPr txBox="1"/>
+          <p:nvPr/>
+        </p:nvSpPr>
+        <p:spPr>
+          <a:xfrm>
+            <a:off x="886968" y="2221992"/>
+            <a:ext cx="3017520" cy="1508760"/>
+          </a:xfrm>
+          <a:prstGeom prst="rect">
+            <a:avLst/>
+          </a:prstGeom>
+          <a:noFill/>
+        </p:spPr>
+        <p:txBody>
+          <a:bodyPr wrap="square">
+            <a:spAutoFit/>
+          </a:bodyPr>
+          <a:lstStyle/>
+          <a:p>
+            <a:pPr algn="l"/>
+            <a:r>
+              <a:rPr sz="1300" b="0">
+                <a:solidFill>
+                  <a:srgbClr val="465266"/>
+                </a:solidFill>
+                <a:latin typeface="Aptos"/>
+              </a:rPr>
+              <a:t>Freeze the pretrained model and train small low-rank adapter matrices. This is the adapter we save, upload, resume, and evaluate.</a:t>
+            </a:r>
+          </a:p>
+        </p:txBody>
+      </p:sp>
+      <p:sp>
+        <p:nvSpPr>
+          <p:cNvPr id="9" name="Rounded Rectangle 8"/>
+          <p:cNvSpPr/>
+          <p:nvPr/>
+        </p:nvSpPr>
+        <p:spPr>
+          <a:xfrm>
+            <a:off x="4389120" y="1691640"/>
+            <a:ext cx="3429000" cy="2148840"/>
+          </a:xfrm>
+          <a:prstGeom prst="roundRect">
+            <a:avLst/>
+          </a:prstGeom>
+          <a:solidFill>
+            <a:srgbClr val="FFFFFF"/>
+          </a:solidFill>
+          <a:ln w="12700">
+            <a:solidFill>
+              <a:srgbClr val="E1E6EB"/>
+            </a:solidFill>
+          </a:ln>
+        </p:spPr>
+        <p:style>
+          <a:lnRef idx="1">
+            <a:schemeClr val="accent1"/>
+          </a:lnRef>
+          <a:fillRef idx="3">
+            <a:schemeClr val="accent1"/>
+          </a:fillRef>
+          <a:effectRef idx="2">
+            <a:schemeClr val="accent1"/>
+          </a:effectRef>
+          <a:fontRef idx="minor">
+            <a:schemeClr val="lt1"/>
+          </a:fontRef>
+        </p:style>
+        <p:txBody>
+          <a:bodyPr rtlCol="0" anchor="ctr"/>
+          <a:lstStyle/>
+          <a:p>
+            <a:pPr algn="ctr"/>
+          </a:p>
+        </p:txBody>
+      </p:sp>
+      <p:sp>
+        <p:nvSpPr>
+          <p:cNvPr id="10" name="Rectangle 9"/>
+          <p:cNvSpPr/>
+          <p:nvPr/>
+        </p:nvSpPr>
+        <p:spPr>
+          <a:xfrm>
+            <a:off x="4389120" y="1691640"/>
+            <a:ext cx="73152" cy="2148840"/>
+          </a:xfrm>
+          <a:prstGeom prst="rect">
+            <a:avLst/>
+          </a:prstGeom>
+          <a:solidFill>
+            <a:srgbClr val="EF7C3A"/>
+          </a:solidFill>
+          <a:ln>
+            <a:noFill/>
+          </a:ln>
+        </p:spPr>
+        <p:style>
+          <a:lnRef idx="1">
+            <a:schemeClr val="accent1"/>
+          </a:lnRef>
+          <a:fillRef idx="3">
+            <a:schemeClr val="accent1"/>
+          </a:fillRef>
+          <a:effectRef idx="2">
+            <a:schemeClr val="accent1"/>
+          </a:effectRef>
+          <a:fontRef idx="minor">
+            <a:schemeClr val="lt1"/>
+          </a:fontRef>
+        </p:style>
+        <p:txBody>
+          <a:bodyPr rtlCol="0" anchor="ctr"/>
+          <a:lstStyle/>
+          <a:p>
+            <a:pPr algn="ctr"/>
+          </a:p>
+        </p:txBody>
+      </p:sp>
+      <p:sp>
+        <p:nvSpPr>
+          <p:cNvPr id="11" name="TextBox 10"/>
+          <p:cNvSpPr txBox="1"/>
+          <p:nvPr/>
+        </p:nvSpPr>
+        <p:spPr>
+          <a:xfrm>
+            <a:off x="4590288" y="1856232"/>
+            <a:ext cx="3017520" cy="274320"/>
+          </a:xfrm>
+          <a:prstGeom prst="rect">
+            <a:avLst/>
+          </a:prstGeom>
+          <a:noFill/>
+        </p:spPr>
+        <p:txBody>
+          <a:bodyPr wrap="square">
+            <a:spAutoFit/>
+          </a:bodyPr>
+          <a:lstStyle/>
+          <a:p>
+            <a:pPr algn="l"/>
+            <a:r>
+              <a:rPr sz="1600" b="1">
+                <a:solidFill>
+                  <a:srgbClr val="0E162B"/>
+                </a:solidFill>
+                <a:latin typeface="Aptos"/>
+              </a:rPr>
+              <a:t>QLoRA-style setup</a:t>
+            </a:r>
+          </a:p>
+        </p:txBody>
+      </p:sp>
+      <p:sp>
+        <p:nvSpPr>
+          <p:cNvPr id="12" name="TextBox 11"/>
+          <p:cNvSpPr txBox="1"/>
+          <p:nvPr/>
+        </p:nvSpPr>
+        <p:spPr>
+          <a:xfrm>
+            <a:off x="4590288" y="2221992"/>
+            <a:ext cx="3017520" cy="1508760"/>
+          </a:xfrm>
+          <a:prstGeom prst="rect">
+            <a:avLst/>
+          </a:prstGeom>
+          <a:noFill/>
+        </p:spPr>
+        <p:txBody>
+          <a:bodyPr wrap="square">
+            <a:spAutoFit/>
+          </a:bodyPr>
+          <a:lstStyle/>
+          <a:p>
+            <a:pPr algn="l"/>
+            <a:r>
+              <a:rPr sz="1300" b="0">
+                <a:solidFill>
+                  <a:srgbClr val="465266"/>
+                </a:solidFill>
+                <a:latin typeface="Aptos"/>
+              </a:rPr>
+              <a:t>Load the base model in 4-bit precision while training LoRA adapters. In our configs this is the load_in_4bit: true path.</a:t>
+            </a:r>
+          </a:p>
+        </p:txBody>
+      </p:sp>
+      <p:sp>
+        <p:nvSpPr>
+          <p:cNvPr id="13" name="Rounded Rectangle 12"/>
+          <p:cNvSpPr/>
+          <p:nvPr/>
+        </p:nvSpPr>
+        <p:spPr>
+          <a:xfrm>
+            <a:off x="8092440" y="1691640"/>
+            <a:ext cx="3429000" cy="2148840"/>
+          </a:xfrm>
+          <a:prstGeom prst="roundRect">
+            <a:avLst/>
+          </a:prstGeom>
+          <a:solidFill>
+            <a:srgbClr val="FFFFFF"/>
+          </a:solidFill>
+          <a:ln w="12700">
+            <a:solidFill>
+              <a:srgbClr val="E1E6EB"/>
+            </a:solidFill>
+          </a:ln>
+        </p:spPr>
+        <p:style>
+          <a:lnRef idx="1">
+            <a:schemeClr val="accent1"/>
+          </a:lnRef>
+          <a:fillRef idx="3">
+            <a:schemeClr val="accent1"/>
+          </a:fillRef>
+          <a:effectRef idx="2">
+            <a:schemeClr val="accent1"/>
+          </a:effectRef>
+          <a:fontRef idx="minor">
+            <a:schemeClr val="lt1"/>
+          </a:fontRef>
+        </p:style>
+        <p:txBody>
+          <a:bodyPr rtlCol="0" anchor="ctr"/>
+          <a:lstStyle/>
+          <a:p>
+            <a:pPr algn="ctr"/>
+          </a:p>
+        </p:txBody>
+      </p:sp>
+      <p:sp>
+        <p:nvSpPr>
+          <p:cNvPr id="14" name="Rectangle 13"/>
+          <p:cNvSpPr/>
+          <p:nvPr/>
+        </p:nvSpPr>
+        <p:spPr>
+          <a:xfrm>
+            <a:off x="8092440" y="1691640"/>
+            <a:ext cx="73152" cy="2148840"/>
+          </a:xfrm>
+          <a:prstGeom prst="rect">
+            <a:avLst/>
+          </a:prstGeom>
+          <a:solidFill>
+            <a:srgbClr val="23847A"/>
+          </a:solidFill>
+          <a:ln>
+            <a:noFill/>
+          </a:ln>
+        </p:spPr>
+        <p:style>
+          <a:lnRef idx="1">
+            <a:schemeClr val="accent1"/>
+          </a:lnRef>
+          <a:fillRef idx="3">
+            <a:schemeClr val="accent1"/>
+          </a:fillRef>
+          <a:effectRef idx="2">
+            <a:schemeClr val="accent1"/>
+          </a:effectRef>
+          <a:fontRef idx="minor">
+            <a:schemeClr val="lt1"/>
+          </a:fontRef>
+        </p:style>
+        <p:txBody>
+          <a:bodyPr rtlCol="0" anchor="ctr"/>
+          <a:lstStyle/>
+          <a:p>
+            <a:pPr algn="ctr"/>
+          </a:p>
+        </p:txBody>
+      </p:sp>
+      <p:sp>
+        <p:nvSpPr>
+          <p:cNvPr id="15" name="TextBox 14"/>
+          <p:cNvSpPr txBox="1"/>
+          <p:nvPr/>
+        </p:nvSpPr>
+        <p:spPr>
+          <a:xfrm>
+            <a:off x="8293608" y="1856232"/>
+            <a:ext cx="3017520" cy="274320"/>
+          </a:xfrm>
+          <a:prstGeom prst="rect">
+            <a:avLst/>
+          </a:prstGeom>
+          <a:noFill/>
+        </p:spPr>
+        <p:txBody>
+          <a:bodyPr wrap="square">
+            <a:spAutoFit/>
+          </a:bodyPr>
+          <a:lstStyle/>
+          <a:p>
+            <a:pPr algn="l"/>
+            <a:r>
+              <a:rPr sz="1600" b="1">
+                <a:solidFill>
+                  <a:srgbClr val="0E162B"/>
+                </a:solidFill>
+                <a:latin typeface="Aptos"/>
+              </a:rPr>
+              <a:t>Not full fine-tuning</a:t>
+            </a:r>
+          </a:p>
+        </p:txBody>
+      </p:sp>
+      <p:sp>
+        <p:nvSpPr>
+          <p:cNvPr id="16" name="TextBox 15"/>
+          <p:cNvSpPr txBox="1"/>
+          <p:nvPr/>
+        </p:nvSpPr>
+        <p:spPr>
+          <a:xfrm>
+            <a:off x="8293608" y="2221992"/>
+            <a:ext cx="3017520" cy="1508760"/>
+          </a:xfrm>
+          <a:prstGeom prst="rect">
+            <a:avLst/>
+          </a:prstGeom>
+          <a:noFill/>
+        </p:spPr>
+        <p:txBody>
+          <a:bodyPr wrap="square">
+            <a:spAutoFit/>
+          </a:bodyPr>
+          <a:lstStyle/>
+          <a:p>
+            <a:pPr algn="l"/>
+            <a:r>
+              <a:rPr sz="1300" b="0">
+                <a:solidFill>
+                  <a:srgbClr val="465266"/>
+                </a:solidFill>
+                <a:latin typeface="Aptos"/>
+              </a:rPr>
+              <a:t>We did not claim full-model weight updates. The public artifacts are PEFT-compatible LoRA adapters plus metrics, logs, and configs.</a:t>
+            </a:r>
+          </a:p>
+        </p:txBody>
+      </p:sp>
+      <p:sp>
+        <p:nvSpPr>
+          <p:cNvPr id="17" name="Rounded Rectangle 16"/>
+          <p:cNvSpPr/>
+          <p:nvPr/>
+        </p:nvSpPr>
+        <p:spPr>
+          <a:xfrm>
+            <a:off x="914400" y="4160520"/>
+            <a:ext cx="10744200" cy="1216152"/>
+          </a:xfrm>
+          <a:prstGeom prst="roundRect">
+            <a:avLst/>
+          </a:prstGeom>
+          <a:solidFill>
+            <a:srgbClr val="0E162B"/>
+          </a:solidFill>
+          <a:ln w="12700">
+            <a:solidFill>
+              <a:srgbClr val="E1E6EB"/>
+            </a:solidFill>
+          </a:ln>
+        </p:spPr>
+        <p:style>
+          <a:lnRef idx="1">
+            <a:schemeClr val="accent1"/>
+          </a:lnRef>
+          <a:fillRef idx="3">
+            <a:schemeClr val="accent1"/>
+          </a:fillRef>
+          <a:effectRef idx="2">
+            <a:schemeClr val="accent1"/>
+          </a:effectRef>
+          <a:fontRef idx="minor">
+            <a:schemeClr val="lt1"/>
+          </a:fontRef>
+        </p:style>
+        <p:txBody>
+          <a:bodyPr rtlCol="0" anchor="ctr"/>
+          <a:lstStyle/>
+          <a:p>
+            <a:pPr algn="ctr"/>
+          </a:p>
+        </p:txBody>
+      </p:sp>
+      <p:sp>
+        <p:nvSpPr>
+          <p:cNvPr id="18" name="Rectangle 17"/>
+          <p:cNvSpPr/>
+          <p:nvPr/>
+        </p:nvSpPr>
+        <p:spPr>
+          <a:xfrm>
+            <a:off x="914400" y="4160520"/>
+            <a:ext cx="73152" cy="1216152"/>
+          </a:xfrm>
+          <a:prstGeom prst="rect">
+            <a:avLst/>
+          </a:prstGeom>
+          <a:solidFill>
+            <a:srgbClr val="EF7C3A"/>
+          </a:solidFill>
+          <a:ln>
+            <a:noFill/>
+          </a:ln>
+        </p:spPr>
+        <p:style>
+          <a:lnRef idx="1">
+            <a:schemeClr val="accent1"/>
+          </a:lnRef>
+          <a:fillRef idx="3">
+            <a:schemeClr val="accent1"/>
+          </a:fillRef>
+          <a:effectRef idx="2">
+            <a:schemeClr val="accent1"/>
+          </a:effectRef>
+          <a:fontRef idx="minor">
+            <a:schemeClr val="lt1"/>
+          </a:fontRef>
+        </p:style>
+        <p:txBody>
+          <a:bodyPr rtlCol="0" anchor="ctr"/>
+          <a:lstStyle/>
+          <a:p>
+            <a:pPr algn="ctr"/>
+          </a:p>
+        </p:txBody>
+      </p:sp>
+      <p:sp>
+        <p:nvSpPr>
+          <p:cNvPr id="19" name="TextBox 18"/>
+          <p:cNvSpPr txBox="1"/>
+          <p:nvPr/>
+        </p:nvSpPr>
+        <p:spPr>
+          <a:xfrm>
+            <a:off x="1115568" y="4325112"/>
+            <a:ext cx="10332720" cy="274320"/>
+          </a:xfrm>
+          <a:prstGeom prst="rect">
+            <a:avLst/>
+          </a:prstGeom>
+          <a:noFill/>
+        </p:spPr>
+        <p:txBody>
+          <a:bodyPr wrap="square">
+            <a:spAutoFit/>
+          </a:bodyPr>
+          <a:lstStyle/>
+          <a:p>
+            <a:pPr algn="l"/>
+            <a:r>
+              <a:rPr sz="1600" b="1">
+                <a:solidFill>
+                  <a:srgbClr val="0E162B"/>
+                </a:solidFill>
+                <a:latin typeface="Aptos"/>
+              </a:rPr>
+              <a:t>Concrete EvacOS2 settings</a:t>
+            </a:r>
+          </a:p>
+        </p:txBody>
+      </p:sp>
+      <p:sp>
+        <p:nvSpPr>
+          <p:cNvPr id="20" name="TextBox 19"/>
+          <p:cNvSpPr txBox="1"/>
+          <p:nvPr/>
+        </p:nvSpPr>
+        <p:spPr>
+          <a:xfrm>
+            <a:off x="1115568" y="4690872"/>
+            <a:ext cx="10332720" cy="576072"/>
+          </a:xfrm>
+          <a:prstGeom prst="rect">
+            <a:avLst/>
+          </a:prstGeom>
+          <a:noFill/>
+        </p:spPr>
+        <p:txBody>
+          <a:bodyPr wrap="square">
+            <a:spAutoFit/>
+          </a:bodyPr>
+          <a:lstStyle/>
+          <a:p>
+            <a:pPr algn="l"/>
+            <a:r>
+              <a:rPr sz="1300" b="0">
+                <a:solidFill>
+                  <a:srgbClr val="465266"/>
+                </a:solidFill>
+                <a:latin typeface="Aptos"/>
+              </a:rPr>
+              <a:t>rank 16, alpha 32, dropout 0.05, target modules q_proj, k_proj, v_proj, o_proj; base models Qwen2.5-3B-Instruct for specialists and Qwen2.5-7B-Instruct for the orchestrator lane.</a:t>
+            </a:r>
+          </a:p>
+        </p:txBody>
+      </p:sp>
+      <p:sp>
+        <p:nvSpPr>
+          <p:cNvPr id="21" name="TextBox 20"/>
+          <p:cNvSpPr txBox="1"/>
+          <p:nvPr/>
+        </p:nvSpPr>
+        <p:spPr>
+          <a:xfrm>
+            <a:off x="1170432" y="4590288"/>
+            <a:ext cx="10195560" cy="256032"/>
+          </a:xfrm>
+          <a:prstGeom prst="rect">
+            <a:avLst/>
+          </a:prstGeom>
+          <a:noFill/>
+        </p:spPr>
+        <p:txBody>
+          <a:bodyPr wrap="square">
+            <a:spAutoFit/>
+          </a:bodyPr>
+          <a:lstStyle/>
+          <a:p>
+            <a:pPr algn="ctr"/>
+            <a:r>
+              <a:rPr sz="1550" b="1">
+                <a:solidFill>
+                  <a:srgbClr val="FFFFFF"/>
+                </a:solidFill>
+                <a:latin typeface="Aptos"/>
+              </a:rPr>
+              <a:t>Judge-facing wording: trained LoRA adapters on a 4-bit loaded base model, not full model retraining.</a:t>
+            </a:r>
+          </a:p>
+        </p:txBody>
+      </p:sp>
+    </p:spTree>
+  </p:cSld>
+  <p:clrMapOvr>
+    <a:masterClrMapping/>
+  </p:clrMapOvr>
+</p:sld>
+</file>
+
+<file path=ppt/slides/slide16.xml><?xml version="1.0" encoding="utf-8"?>
+<p:sld xmlns:a="http://schemas.openxmlformats.org/drawingml/2006/main" xmlns:p="http://schemas.openxmlformats.org/presentationml/2006/main" xmlns:r="http://schemas.openxmlformats.org/officeDocument/2006/relationships">
+  <p:cSld>
+    <p:spTree>
+      <p:nvGrpSpPr>
+        <p:cNvPr id="1" name=""/>
+        <p:cNvGrpSpPr/>
+        <p:nvPr/>
+      </p:nvGrpSpPr>
+      <p:grpSpPr/>
+      <p:sp>
+        <p:nvSpPr>
+          <p:cNvPr id="2" name="Rectangle 1"/>
+          <p:cNvSpPr/>
+          <p:nvPr/>
+        </p:nvSpPr>
+        <p:spPr>
+          <a:xfrm>
+            <a:off x="0" y="0"/>
+            <a:ext cx="12191695" cy="6858000"/>
+          </a:xfrm>
+          <a:prstGeom prst="rect">
+            <a:avLst/>
+          </a:prstGeom>
+          <a:solidFill>
+            <a:srgbClr val="F8F4E8"/>
+          </a:solidFill>
+          <a:ln>
+            <a:noFill/>
+          </a:ln>
+        </p:spPr>
+        <p:style>
+          <a:lnRef idx="1">
+            <a:schemeClr val="accent1"/>
+          </a:lnRef>
+          <a:fillRef idx="3">
+            <a:schemeClr val="accent1"/>
+          </a:fillRef>
+          <a:effectRef idx="2">
+            <a:schemeClr val="accent1"/>
+          </a:effectRef>
+          <a:fontRef idx="minor">
+            <a:schemeClr val="lt1"/>
+          </a:fontRef>
+        </p:style>
+        <p:txBody>
+          <a:bodyPr rtlCol="0" anchor="ctr"/>
+          <a:lstStyle/>
+          <a:p>
+            <a:pPr algn="ctr"/>
+          </a:p>
+        </p:txBody>
+      </p:sp>
+      <p:sp>
+        <p:nvSpPr>
+          <p:cNvPr id="3" name="TextBox 2"/>
+          <p:cNvSpPr txBox="1"/>
+          <p:nvPr/>
+        </p:nvSpPr>
+        <p:spPr>
+          <a:xfrm>
+            <a:off x="594360" y="384048"/>
+            <a:ext cx="10972800" cy="457200"/>
+          </a:xfrm>
+          <a:prstGeom prst="rect">
+            <a:avLst/>
+          </a:prstGeom>
+          <a:noFill/>
+        </p:spPr>
+        <p:txBody>
+          <a:bodyPr wrap="square">
+            <a:spAutoFit/>
+          </a:bodyPr>
+          <a:lstStyle/>
+          <a:p>
+            <a:pPr algn="l"/>
+            <a:r>
+              <a:rPr sz="1500" b="1">
+                <a:solidFill>
+                  <a:srgbClr val="EF7C3A"/>
+                </a:solidFill>
+                <a:latin typeface="Aptos"/>
+              </a:rPr>
+              <a:t>TRAINING LOOP</a:t>
+            </a:r>
+          </a:p>
+        </p:txBody>
+      </p:sp>
+      <p:sp>
+        <p:nvSpPr>
+          <p:cNvPr id="4" name="TextBox 3"/>
+          <p:cNvSpPr txBox="1"/>
+          <p:nvPr/>
+        </p:nvSpPr>
+        <p:spPr>
+          <a:xfrm>
+            <a:off x="594360" y="804672"/>
+            <a:ext cx="10789920" cy="713232"/>
+          </a:xfrm>
+          <a:prstGeom prst="rect">
+            <a:avLst/>
+          </a:prstGeom>
+          <a:noFill/>
+        </p:spPr>
+        <p:txBody>
+          <a:bodyPr wrap="square">
+            <a:spAutoFit/>
+          </a:bodyPr>
+          <a:lstStyle/>
+          <a:p>
+            <a:pPr algn="l"/>
+            <a:r>
+              <a:rPr sz="3000" b="1">
+                <a:solidFill>
+                  <a:srgbClr val="0E162B"/>
+                </a:solidFill>
+                <a:latin typeface="Georgia"/>
+              </a:rPr>
+              <a:t>How a step becomes evidence</a:t>
+            </a:r>
+          </a:p>
+        </p:txBody>
+      </p:sp>
+      <p:sp>
+        <p:nvSpPr>
+          <p:cNvPr id="5" name="Rounded Rectangle 4"/>
+          <p:cNvSpPr/>
+          <p:nvPr/>
+        </p:nvSpPr>
+        <p:spPr>
+          <a:xfrm>
+            <a:off x="960120" y="1554480"/>
+            <a:ext cx="10287000" cy="603504"/>
+          </a:xfrm>
+          <a:prstGeom prst="roundRect">
+            <a:avLst/>
+          </a:prstGeom>
+          <a:solidFill>
+            <a:srgbClr val="FFFFFF"/>
+          </a:solidFill>
+          <a:ln w="12700">
+            <a:solidFill>
+              <a:srgbClr val="E1E6EB"/>
+            </a:solidFill>
+          </a:ln>
+        </p:spPr>
+        <p:style>
+          <a:lnRef idx="1">
+            <a:schemeClr val="accent1"/>
+          </a:lnRef>
+          <a:fillRef idx="3">
+            <a:schemeClr val="accent1"/>
+          </a:fillRef>
+          <a:effectRef idx="2">
+            <a:schemeClr val="accent1"/>
+          </a:effectRef>
+          <a:fontRef idx="minor">
+            <a:schemeClr val="lt1"/>
+          </a:fontRef>
+        </p:style>
+        <p:txBody>
+          <a:bodyPr rtlCol="0" anchor="ctr"/>
+          <a:lstStyle/>
+          <a:p>
+            <a:pPr algn="ctr"/>
+          </a:p>
+        </p:txBody>
+      </p:sp>
+      <p:sp>
+        <p:nvSpPr>
+          <p:cNvPr id="6" name="Rectangle 5"/>
+          <p:cNvSpPr/>
+          <p:nvPr/>
+        </p:nvSpPr>
+        <p:spPr>
+          <a:xfrm>
+            <a:off x="960120" y="1554480"/>
+            <a:ext cx="73152" cy="603504"/>
+          </a:xfrm>
+          <a:prstGeom prst="rect">
+            <a:avLst/>
+          </a:prstGeom>
+          <a:solidFill>
+            <a:srgbClr val="23847A"/>
+          </a:solidFill>
+          <a:ln>
+            <a:noFill/>
+          </a:ln>
+        </p:spPr>
+        <p:style>
+          <a:lnRef idx="1">
+            <a:schemeClr val="accent1"/>
+          </a:lnRef>
+          <a:fillRef idx="3">
+            <a:schemeClr val="accent1"/>
+          </a:fillRef>
+          <a:effectRef idx="2">
+            <a:schemeClr val="accent1"/>
+          </a:effectRef>
+          <a:fontRef idx="minor">
+            <a:schemeClr val="lt1"/>
+          </a:fontRef>
+        </p:style>
+        <p:txBody>
+          <a:bodyPr rtlCol="0" anchor="ctr"/>
+          <a:lstStyle/>
+          <a:p>
+            <a:pPr algn="ctr"/>
+          </a:p>
+        </p:txBody>
+      </p:sp>
+      <p:sp>
+        <p:nvSpPr>
+          <p:cNvPr id="7" name="TextBox 6"/>
+          <p:cNvSpPr txBox="1"/>
+          <p:nvPr/>
+        </p:nvSpPr>
+        <p:spPr>
+          <a:xfrm>
+            <a:off x="1161288" y="1719072"/>
+            <a:ext cx="9875520" cy="274320"/>
+          </a:xfrm>
+          <a:prstGeom prst="rect">
+            <a:avLst/>
+          </a:prstGeom>
+          <a:noFill/>
+        </p:spPr>
+        <p:txBody>
+          <a:bodyPr wrap="square">
+            <a:spAutoFit/>
+          </a:bodyPr>
+          <a:lstStyle/>
+          <a:p>
+            <a:pPr algn="l"/>
+            <a:r>
+              <a:rPr sz="1600" b="1">
+                <a:solidFill>
+                  <a:srgbClr val="0E162B"/>
+                </a:solidFill>
+                <a:latin typeface="Aptos"/>
+              </a:rPr>
+              <a:t>1. Sample episodes</a:t>
+            </a:r>
+          </a:p>
+        </p:txBody>
+      </p:sp>
+      <p:sp>
+        <p:nvSpPr>
+          <p:cNvPr id="8" name="TextBox 7"/>
+          <p:cNvSpPr txBox="1"/>
+          <p:nvPr/>
+        </p:nvSpPr>
+        <p:spPr>
+          <a:xfrm>
+            <a:off x="1161288" y="2084831"/>
+            <a:ext cx="9875520" cy="-36575"/>
+          </a:xfrm>
+          <a:prstGeom prst="rect">
+            <a:avLst/>
+          </a:prstGeom>
+          <a:noFill/>
+        </p:spPr>
+        <p:txBody>
+          <a:bodyPr wrap="square">
+            <a:spAutoFit/>
+          </a:bodyPr>
+          <a:lstStyle/>
+          <a:p>
+            <a:pPr algn="l"/>
+            <a:r>
+              <a:rPr sz="1300" b="0">
+                <a:solidFill>
+                  <a:srgbClr val="465266"/>
+                </a:solidFill>
+                <a:latin typeface="Aptos"/>
+              </a:rPr>
+              <a:t>Fire, flood, and gas resets produce structured multi-agent observations.</a:t>
+            </a:r>
+          </a:p>
+        </p:txBody>
+      </p:sp>
+      <p:sp>
+        <p:nvSpPr>
+          <p:cNvPr id="9" name="Rounded Rectangle 8"/>
+          <p:cNvSpPr/>
+          <p:nvPr/>
+        </p:nvSpPr>
+        <p:spPr>
+          <a:xfrm>
+            <a:off x="960120" y="2331720"/>
+            <a:ext cx="10287000" cy="603504"/>
+          </a:xfrm>
+          <a:prstGeom prst="roundRect">
+            <a:avLst/>
+          </a:prstGeom>
+          <a:solidFill>
+            <a:srgbClr val="FFFFFF"/>
+          </a:solidFill>
+          <a:ln w="12700">
+            <a:solidFill>
+              <a:srgbClr val="E1E6EB"/>
+            </a:solidFill>
+          </a:ln>
+        </p:spPr>
+        <p:style>
+          <a:lnRef idx="1">
+            <a:schemeClr val="accent1"/>
+          </a:lnRef>
+          <a:fillRef idx="3">
+            <a:schemeClr val="accent1"/>
+          </a:fillRef>
+          <a:effectRef idx="2">
+            <a:schemeClr val="accent1"/>
+          </a:effectRef>
+          <a:fontRef idx="minor">
+            <a:schemeClr val="lt1"/>
+          </a:fontRef>
+        </p:style>
+        <p:txBody>
+          <a:bodyPr rtlCol="0" anchor="ctr"/>
+          <a:lstStyle/>
+          <a:p>
+            <a:pPr algn="ctr"/>
+          </a:p>
+        </p:txBody>
+      </p:sp>
+      <p:sp>
+        <p:nvSpPr>
+          <p:cNvPr id="10" name="Rectangle 9"/>
+          <p:cNvSpPr/>
+          <p:nvPr/>
+        </p:nvSpPr>
+        <p:spPr>
+          <a:xfrm>
+            <a:off x="960120" y="2331720"/>
+            <a:ext cx="73152" cy="603504"/>
+          </a:xfrm>
+          <a:prstGeom prst="rect">
+            <a:avLst/>
+          </a:prstGeom>
+          <a:solidFill>
+            <a:srgbClr val="EF7C3A"/>
+          </a:solidFill>
+          <a:ln>
+            <a:noFill/>
+          </a:ln>
+        </p:spPr>
+        <p:style>
+          <a:lnRef idx="1">
+            <a:schemeClr val="accent1"/>
+          </a:lnRef>
+          <a:fillRef idx="3">
+            <a:schemeClr val="accent1"/>
+          </a:fillRef>
+          <a:effectRef idx="2">
+            <a:schemeClr val="accent1"/>
+          </a:effectRef>
+          <a:fontRef idx="minor">
+            <a:schemeClr val="lt1"/>
+          </a:fontRef>
+        </p:style>
+        <p:txBody>
+          <a:bodyPr rtlCol="0" anchor="ctr"/>
+          <a:lstStyle/>
+          <a:p>
+            <a:pPr algn="ctr"/>
+          </a:p>
+        </p:txBody>
+      </p:sp>
+      <p:sp>
+        <p:nvSpPr>
+          <p:cNvPr id="11" name="TextBox 10"/>
+          <p:cNvSpPr txBox="1"/>
+          <p:nvPr/>
+        </p:nvSpPr>
+        <p:spPr>
+          <a:xfrm>
+            <a:off x="1161288" y="2496312"/>
+            <a:ext cx="9875520" cy="274320"/>
+          </a:xfrm>
+          <a:prstGeom prst="rect">
+            <a:avLst/>
+          </a:prstGeom>
+          <a:noFill/>
+        </p:spPr>
+        <p:txBody>
+          <a:bodyPr wrap="square">
+            <a:spAutoFit/>
+          </a:bodyPr>
+          <a:lstStyle/>
+          <a:p>
+            <a:pPr algn="l"/>
+            <a:r>
+              <a:rPr sz="1600" b="1">
+                <a:solidFill>
+                  <a:srgbClr val="0E162B"/>
+                </a:solidFill>
+                <a:latin typeface="Aptos"/>
+              </a:rPr>
+              <a:t>2. Generate actions</a:t>
+            </a:r>
+          </a:p>
+        </p:txBody>
+      </p:sp>
+      <p:sp>
+        <p:nvSpPr>
+          <p:cNvPr id="12" name="TextBox 11"/>
+          <p:cNvSpPr txBox="1"/>
+          <p:nvPr/>
+        </p:nvSpPr>
+        <p:spPr>
+          <a:xfrm>
+            <a:off x="1161288" y="2862072"/>
+            <a:ext cx="9875520" cy="-36575"/>
+          </a:xfrm>
+          <a:prstGeom prst="rect">
+            <a:avLst/>
+          </a:prstGeom>
+          <a:noFill/>
+        </p:spPr>
+        <p:txBody>
+          <a:bodyPr wrap="square">
+            <a:spAutoFit/>
+          </a:bodyPr>
+          <a:lstStyle/>
+          <a:p>
+            <a:pPr algn="l"/>
+            <a:r>
+              <a:rPr sz="1300" b="0">
+                <a:solidFill>
+                  <a:srgbClr val="465266"/>
+                </a:solidFill>
+                <a:latin typeface="Aptos"/>
+              </a:rPr>
+              <a:t>Floor agents and the orchestrator emit schema-bound actions, not free-form plans.</a:t>
+            </a:r>
+          </a:p>
+        </p:txBody>
+      </p:sp>
+      <p:sp>
+        <p:nvSpPr>
+          <p:cNvPr id="13" name="Rounded Rectangle 12"/>
+          <p:cNvSpPr/>
+          <p:nvPr/>
+        </p:nvSpPr>
+        <p:spPr>
+          <a:xfrm>
+            <a:off x="960120" y="3108960"/>
+            <a:ext cx="10287000" cy="603504"/>
+          </a:xfrm>
+          <a:prstGeom prst="roundRect">
+            <a:avLst/>
+          </a:prstGeom>
+          <a:solidFill>
+            <a:srgbClr val="FFFFFF"/>
+          </a:solidFill>
+          <a:ln w="12700">
+            <a:solidFill>
+              <a:srgbClr val="E1E6EB"/>
+            </a:solidFill>
+          </a:ln>
+        </p:spPr>
+        <p:style>
+          <a:lnRef idx="1">
+            <a:schemeClr val="accent1"/>
+          </a:lnRef>
+          <a:fillRef idx="3">
+            <a:schemeClr val="accent1"/>
+          </a:fillRef>
+          <a:effectRef idx="2">
+            <a:schemeClr val="accent1"/>
+          </a:effectRef>
+          <a:fontRef idx="minor">
+            <a:schemeClr val="lt1"/>
+          </a:fontRef>
+        </p:style>
+        <p:txBody>
+          <a:bodyPr rtlCol="0" anchor="ctr"/>
+          <a:lstStyle/>
+          <a:p>
+            <a:pPr algn="ctr"/>
+          </a:p>
+        </p:txBody>
+      </p:sp>
+      <p:sp>
+        <p:nvSpPr>
+          <p:cNvPr id="14" name="Rectangle 13"/>
+          <p:cNvSpPr/>
+          <p:nvPr/>
+        </p:nvSpPr>
+        <p:spPr>
+          <a:xfrm>
+            <a:off x="960120" y="3108960"/>
+            <a:ext cx="73152" cy="603504"/>
+          </a:xfrm>
+          <a:prstGeom prst="rect">
+            <a:avLst/>
+          </a:prstGeom>
+          <a:solidFill>
+            <a:srgbClr val="23847A"/>
+          </a:solidFill>
+          <a:ln>
+            <a:noFill/>
+          </a:ln>
+        </p:spPr>
+        <p:style>
+          <a:lnRef idx="1">
+            <a:schemeClr val="accent1"/>
+          </a:lnRef>
+          <a:fillRef idx="3">
+            <a:schemeClr val="accent1"/>
+          </a:fillRef>
+          <a:effectRef idx="2">
+            <a:schemeClr val="accent1"/>
+          </a:effectRef>
+          <a:fontRef idx="minor">
+            <a:schemeClr val="lt1"/>
+          </a:fontRef>
+        </p:style>
+        <p:txBody>
+          <a:bodyPr rtlCol="0" anchor="ctr"/>
+          <a:lstStyle/>
+          <a:p>
+            <a:pPr algn="ctr"/>
+          </a:p>
+        </p:txBody>
+      </p:sp>
+      <p:sp>
+        <p:nvSpPr>
+          <p:cNvPr id="15" name="TextBox 14"/>
+          <p:cNvSpPr txBox="1"/>
+          <p:nvPr/>
+        </p:nvSpPr>
+        <p:spPr>
+          <a:xfrm>
+            <a:off x="1161288" y="3273552"/>
+            <a:ext cx="9875520" cy="274320"/>
+          </a:xfrm>
+          <a:prstGeom prst="rect">
+            <a:avLst/>
+          </a:prstGeom>
+          <a:noFill/>
+        </p:spPr>
+        <p:txBody>
+          <a:bodyPr wrap="square">
+            <a:spAutoFit/>
+          </a:bodyPr>
+          <a:lstStyle/>
+          <a:p>
+            <a:pPr algn="l"/>
+            <a:r>
+              <a:rPr sz="1600" b="1">
+                <a:solidFill>
+                  <a:srgbClr val="0E162B"/>
+                </a:solidFill>
+                <a:latin typeface="Aptos"/>
+              </a:rPr>
+              <a:t>3. Validate and reward</a:t>
+            </a:r>
+          </a:p>
+        </p:txBody>
+      </p:sp>
+      <p:sp>
+        <p:nvSpPr>
+          <p:cNvPr id="16" name="TextBox 15"/>
+          <p:cNvSpPr txBox="1"/>
+          <p:nvPr/>
+        </p:nvSpPr>
+        <p:spPr>
+          <a:xfrm>
+            <a:off x="1161288" y="3639312"/>
+            <a:ext cx="9875520" cy="-36575"/>
+          </a:xfrm>
+          <a:prstGeom prst="rect">
+            <a:avLst/>
+          </a:prstGeom>
+          <a:noFill/>
+        </p:spPr>
+        <p:txBody>
+          <a:bodyPr wrap="square">
+            <a:spAutoFit/>
+          </a:bodyPr>
+          <a:lstStyle/>
+          <a:p>
+            <a:pPr algn="l"/>
+            <a:r>
+              <a:rPr sz="1300" b="0">
+                <a:solidFill>
+                  <a:srgbClr val="465266"/>
+                </a:solidFill>
+                <a:latin typeface="Aptos"/>
+              </a:rPr>
+              <a:t>Parser, route-target checks, invalid-action penalties, and disaster rewards create the signal.</a:t>
+            </a:r>
+          </a:p>
+        </p:txBody>
+      </p:sp>
+      <p:sp>
+        <p:nvSpPr>
+          <p:cNvPr id="17" name="Rounded Rectangle 16"/>
+          <p:cNvSpPr/>
+          <p:nvPr/>
+        </p:nvSpPr>
+        <p:spPr>
+          <a:xfrm>
+            <a:off x="960120" y="3886200"/>
+            <a:ext cx="10287000" cy="603504"/>
+          </a:xfrm>
+          <a:prstGeom prst="roundRect">
+            <a:avLst/>
+          </a:prstGeom>
+          <a:solidFill>
+            <a:srgbClr val="FFFFFF"/>
+          </a:solidFill>
+          <a:ln w="12700">
+            <a:solidFill>
+              <a:srgbClr val="E1E6EB"/>
+            </a:solidFill>
+          </a:ln>
+        </p:spPr>
+        <p:style>
+          <a:lnRef idx="1">
+            <a:schemeClr val="accent1"/>
+          </a:lnRef>
+          <a:fillRef idx="3">
+            <a:schemeClr val="accent1"/>
+          </a:fillRef>
+          <a:effectRef idx="2">
+            <a:schemeClr val="accent1"/>
+          </a:effectRef>
+          <a:fontRef idx="minor">
+            <a:schemeClr val="lt1"/>
+          </a:fontRef>
+        </p:style>
+        <p:txBody>
+          <a:bodyPr rtlCol="0" anchor="ctr"/>
+          <a:lstStyle/>
+          <a:p>
+            <a:pPr algn="ctr"/>
+          </a:p>
+        </p:txBody>
+      </p:sp>
+      <p:sp>
+        <p:nvSpPr>
+          <p:cNvPr id="18" name="Rectangle 17"/>
+          <p:cNvSpPr/>
+          <p:nvPr/>
+        </p:nvSpPr>
+        <p:spPr>
+          <a:xfrm>
+            <a:off x="960120" y="3886200"/>
+            <a:ext cx="73152" cy="603504"/>
+          </a:xfrm>
+          <a:prstGeom prst="rect">
+            <a:avLst/>
+          </a:prstGeom>
+          <a:solidFill>
+            <a:srgbClr val="EF7C3A"/>
+          </a:solidFill>
+          <a:ln>
+            <a:noFill/>
+          </a:ln>
+        </p:spPr>
+        <p:style>
+          <a:lnRef idx="1">
+            <a:schemeClr val="accent1"/>
+          </a:lnRef>
+          <a:fillRef idx="3">
+            <a:schemeClr val="accent1"/>
+          </a:fillRef>
+          <a:effectRef idx="2">
+            <a:schemeClr val="accent1"/>
+          </a:effectRef>
+          <a:fontRef idx="minor">
+            <a:schemeClr val="lt1"/>
+          </a:fontRef>
+        </p:style>
+        <p:txBody>
+          <a:bodyPr rtlCol="0" anchor="ctr"/>
+          <a:lstStyle/>
+          <a:p>
+            <a:pPr algn="ctr"/>
+          </a:p>
+        </p:txBody>
+      </p:sp>
+      <p:sp>
+        <p:nvSpPr>
+          <p:cNvPr id="19" name="TextBox 18"/>
+          <p:cNvSpPr txBox="1"/>
+          <p:nvPr/>
+        </p:nvSpPr>
+        <p:spPr>
+          <a:xfrm>
+            <a:off x="1161288" y="4050791"/>
+            <a:ext cx="9875520" cy="274320"/>
+          </a:xfrm>
+          <a:prstGeom prst="rect">
+            <a:avLst/>
+          </a:prstGeom>
+          <a:noFill/>
+        </p:spPr>
+        <p:txBody>
+          <a:bodyPr wrap="square">
+            <a:spAutoFit/>
+          </a:bodyPr>
+          <a:lstStyle/>
+          <a:p>
+            <a:pPr algn="l"/>
+            <a:r>
+              <a:rPr sz="1600" b="1">
+                <a:solidFill>
+                  <a:srgbClr val="0E162B"/>
+                </a:solidFill>
+                <a:latin typeface="Aptos"/>
+              </a:rPr>
+              <a:t>4. GRPO-family update</a:t>
+            </a:r>
+          </a:p>
+        </p:txBody>
+      </p:sp>
+      <p:sp>
+        <p:nvSpPr>
+          <p:cNvPr id="20" name="TextBox 19"/>
+          <p:cNvSpPr txBox="1"/>
+          <p:nvPr/>
+        </p:nvSpPr>
+        <p:spPr>
+          <a:xfrm>
+            <a:off x="1161288" y="4416552"/>
+            <a:ext cx="9875520" cy="-36575"/>
+          </a:xfrm>
+          <a:prstGeom prst="rect">
+            <a:avLst/>
+          </a:prstGeom>
+          <a:noFill/>
+        </p:spPr>
+        <p:txBody>
+          <a:bodyPr wrap="square">
+            <a:spAutoFit/>
+          </a:bodyPr>
+          <a:lstStyle/>
+          <a:p>
+            <a:pPr algn="l"/>
+            <a:r>
+              <a:rPr sz="1300" b="0">
+                <a:solidFill>
+                  <a:srgbClr val="465266"/>
+                </a:solidFill>
+                <a:latin typeface="Aptos"/>
+              </a:rPr>
+              <a:t>Grouped rewards train LoRA adapters while KL keeps the policy from drifting too far.</a:t>
+            </a:r>
+          </a:p>
+        </p:txBody>
+      </p:sp>
+      <p:sp>
+        <p:nvSpPr>
+          <p:cNvPr id="21" name="Rounded Rectangle 20"/>
+          <p:cNvSpPr/>
+          <p:nvPr/>
+        </p:nvSpPr>
+        <p:spPr>
+          <a:xfrm>
+            <a:off x="960120" y="4663440"/>
+            <a:ext cx="10287000" cy="603504"/>
+          </a:xfrm>
+          <a:prstGeom prst="roundRect">
+            <a:avLst/>
+          </a:prstGeom>
+          <a:solidFill>
+            <a:srgbClr val="FFFFFF"/>
+          </a:solidFill>
+          <a:ln w="12700">
+            <a:solidFill>
+              <a:srgbClr val="E1E6EB"/>
+            </a:solidFill>
+          </a:ln>
+        </p:spPr>
+        <p:style>
+          <a:lnRef idx="1">
+            <a:schemeClr val="accent1"/>
+          </a:lnRef>
+          <a:fillRef idx="3">
+            <a:schemeClr val="accent1"/>
+          </a:fillRef>
+          <a:effectRef idx="2">
+            <a:schemeClr val="accent1"/>
+          </a:effectRef>
+          <a:fontRef idx="minor">
+            <a:schemeClr val="lt1"/>
+          </a:fontRef>
+        </p:style>
+        <p:txBody>
+          <a:bodyPr rtlCol="0" anchor="ctr"/>
+          <a:lstStyle/>
+          <a:p>
+            <a:pPr algn="ctr"/>
+          </a:p>
+        </p:txBody>
+      </p:sp>
+      <p:sp>
+        <p:nvSpPr>
+          <p:cNvPr id="22" name="Rectangle 21"/>
+          <p:cNvSpPr/>
+          <p:nvPr/>
+        </p:nvSpPr>
+        <p:spPr>
+          <a:xfrm>
+            <a:off x="960120" y="4663440"/>
+            <a:ext cx="73152" cy="603504"/>
+          </a:xfrm>
+          <a:prstGeom prst="rect">
+            <a:avLst/>
+          </a:prstGeom>
+          <a:solidFill>
+            <a:srgbClr val="23847A"/>
+          </a:solidFill>
+          <a:ln>
+            <a:noFill/>
+          </a:ln>
+        </p:spPr>
+        <p:style>
+          <a:lnRef idx="1">
+            <a:schemeClr val="accent1"/>
+          </a:lnRef>
+          <a:fillRef idx="3">
+            <a:schemeClr val="accent1"/>
+          </a:fillRef>
+          <a:effectRef idx="2">
+            <a:schemeClr val="accent1"/>
+          </a:effectRef>
+          <a:fontRef idx="minor">
+            <a:schemeClr val="lt1"/>
+          </a:fontRef>
+        </p:style>
+        <p:txBody>
+          <a:bodyPr rtlCol="0" anchor="ctr"/>
+          <a:lstStyle/>
+          <a:p>
+            <a:pPr algn="ctr"/>
+          </a:p>
+        </p:txBody>
+      </p:sp>
+      <p:sp>
+        <p:nvSpPr>
+          <p:cNvPr id="23" name="TextBox 22"/>
+          <p:cNvSpPr txBox="1"/>
+          <p:nvPr/>
+        </p:nvSpPr>
+        <p:spPr>
+          <a:xfrm>
+            <a:off x="1161288" y="4828031"/>
+            <a:ext cx="9875520" cy="274320"/>
+          </a:xfrm>
+          <a:prstGeom prst="rect">
+            <a:avLst/>
+          </a:prstGeom>
+          <a:noFill/>
+        </p:spPr>
+        <p:txBody>
+          <a:bodyPr wrap="square">
+            <a:spAutoFit/>
+          </a:bodyPr>
+          <a:lstStyle/>
+          <a:p>
+            <a:pPr algn="l"/>
+            <a:r>
+              <a:rPr sz="1600" b="1">
+                <a:solidFill>
+                  <a:srgbClr val="0E162B"/>
+                </a:solidFill>
+                <a:latin typeface="Aptos"/>
+              </a:rPr>
+              <a:t>5. Save evidence</a:t>
+            </a:r>
+          </a:p>
+        </p:txBody>
+      </p:sp>
+      <p:sp>
+        <p:nvSpPr>
+          <p:cNvPr id="24" name="TextBox 23"/>
+          <p:cNvSpPr txBox="1"/>
+          <p:nvPr/>
+        </p:nvSpPr>
+        <p:spPr>
+          <a:xfrm>
+            <a:off x="1161288" y="5193792"/>
+            <a:ext cx="9875520" cy="-36575"/>
+          </a:xfrm>
+          <a:prstGeom prst="rect">
+            <a:avLst/>
+          </a:prstGeom>
+          <a:noFill/>
+        </p:spPr>
+        <p:txBody>
+          <a:bodyPr wrap="square">
+            <a:spAutoFit/>
+          </a:bodyPr>
+          <a:lstStyle/>
+          <a:p>
+            <a:pPr algn="l"/>
+            <a:r>
+              <a:rPr sz="1300" b="0">
+                <a:solidFill>
+                  <a:srgbClr val="465266"/>
+                </a:solidFill>
+                <a:latin typeface="Aptos"/>
+              </a:rPr>
+              <a:t>Checkpoints, CSV metrics, JSONL traces, plots, and held-out scorecards are published separately from the base model.</a:t>
+            </a:r>
+          </a:p>
+        </p:txBody>
+      </p:sp>
+      <p:sp>
+        <p:nvSpPr>
+          <p:cNvPr id="25" name="TextBox 24"/>
+          <p:cNvSpPr txBox="1"/>
+          <p:nvPr/>
+        </p:nvSpPr>
+        <p:spPr>
+          <a:xfrm>
+            <a:off x="960120" y="5650992"/>
+            <a:ext cx="10287000" cy="320040"/>
+          </a:xfrm>
+          <a:prstGeom prst="rect">
+            <a:avLst/>
+          </a:prstGeom>
+          <a:noFill/>
+        </p:spPr>
+        <p:txBody>
+          <a:bodyPr wrap="square">
+            <a:spAutoFit/>
+          </a:bodyPr>
+          <a:lstStyle/>
+          <a:p>
+            <a:pPr algn="ctr"/>
+            <a:r>
+              <a:rPr sz="1450" b="1">
+                <a:solidFill>
+                  <a:srgbClr val="0E162B"/>
+                </a:solidFill>
+                <a:latin typeface="Aptos"/>
+              </a:rPr>
+              <a:t>The important split: training reward can be messy and diagnostic, while held-out evaluation stays bounded, readable, and judge-facing.</a:t>
             </a:r>
           </a:p>
         </p:txBody>

</xml_diff>